<commit_message>
docs: strategy v2.1 marketing psychology + pitch deck layout fix
Strategy: Jobs-to-Be-Done (feature→job table), First 10 Minutes
Experience (activation energy), funnel 7-touch strutturato, pricing
psychology (daily frame, costo inazione, pratfall, referral corretto),
Zeigarnik engagement loop nella community PRO.
Pitch deck: fix layout slide 10/12/13 (sovrapposizioni e overflow).

Co-Authored-By: Claude Opus 4.6 (1M context) <noreply@anthropic.com>
</commit_message>
<xml_diff>
--- a/docs/FitManager_PitchDeck.pptx
+++ b/docs/FitManager_PitchDeck.pptx
@@ -3753,7 +3753,7 @@
         </p:nvSpPr>
         <p:spPr>
           <a:xfrm>
-            <a:off x="1005840" y="1188720"/>
+            <a:off x="1005840" y="1051560"/>
             <a:ext cx="411480" cy="411480"/>
           </a:xfrm>
           <a:prstGeom prst="ellipse">
@@ -3773,7 +3773,7 @@
         </p:nvSpPr>
         <p:spPr>
           <a:xfrm>
-            <a:off x="1005840" y="1188720"/>
+            <a:off x="1005840" y="1051560"/>
             <a:ext cx="411480" cy="411480"/>
           </a:xfrm>
           <a:prstGeom prst="rect">
@@ -3812,7 +3812,7 @@
         </p:nvSpPr>
         <p:spPr>
           <a:xfrm>
-            <a:off x="1508760" y="1394460"/>
+            <a:off x="1508760" y="1257300"/>
             <a:ext cx="1280160" cy="0"/>
           </a:xfrm>
           <a:prstGeom prst="line">
@@ -3835,8 +3835,8 @@
         </p:nvSpPr>
         <p:spPr>
           <a:xfrm>
-            <a:off x="274320" y="1691640"/>
-            <a:ext cx="1920240" cy="256032"/>
+            <a:off x="274320" y="1554480"/>
+            <a:ext cx="1920240" cy="228600"/>
           </a:xfrm>
           <a:prstGeom prst="rect">
             <a:avLst/>
@@ -3874,8 +3874,8 @@
         </p:nvSpPr>
         <p:spPr>
           <a:xfrm>
-            <a:off x="274320" y="1901952"/>
-            <a:ext cx="1920240" cy="182880"/>
+            <a:off x="274320" y="1755648"/>
+            <a:ext cx="1920240" cy="164592"/>
           </a:xfrm>
           <a:prstGeom prst="rect">
             <a:avLst/>
@@ -3913,8 +3913,8 @@
         </p:nvSpPr>
         <p:spPr>
           <a:xfrm>
-            <a:off x="365760" y="2148840"/>
-            <a:ext cx="1737360" cy="685800"/>
+            <a:off x="365760" y="1965960"/>
+            <a:ext cx="1737360" cy="640080"/>
           </a:xfrm>
           <a:prstGeom prst="rect">
             <a:avLst/>
@@ -3986,7 +3986,7 @@
         </p:nvSpPr>
         <p:spPr>
           <a:xfrm>
-            <a:off x="3246120" y="1188720"/>
+            <a:off x="3246120" y="1051560"/>
             <a:ext cx="411480" cy="411480"/>
           </a:xfrm>
           <a:prstGeom prst="ellipse">
@@ -4006,7 +4006,7 @@
         </p:nvSpPr>
         <p:spPr>
           <a:xfrm>
-            <a:off x="3246120" y="1188720"/>
+            <a:off x="3246120" y="1051560"/>
             <a:ext cx="411480" cy="411480"/>
           </a:xfrm>
           <a:prstGeom prst="rect">
@@ -4045,7 +4045,7 @@
         </p:nvSpPr>
         <p:spPr>
           <a:xfrm>
-            <a:off x="3749040" y="1394460"/>
+            <a:off x="3749040" y="1257300"/>
             <a:ext cx="1280160" cy="0"/>
           </a:xfrm>
           <a:prstGeom prst="line">
@@ -4068,8 +4068,8 @@
         </p:nvSpPr>
         <p:spPr>
           <a:xfrm>
-            <a:off x="2514600" y="1691640"/>
-            <a:ext cx="1920240" cy="256032"/>
+            <a:off x="2514600" y="1554480"/>
+            <a:ext cx="1920240" cy="228600"/>
           </a:xfrm>
           <a:prstGeom prst="rect">
             <a:avLst/>
@@ -4107,8 +4107,8 @@
         </p:nvSpPr>
         <p:spPr>
           <a:xfrm>
-            <a:off x="2514600" y="1901952"/>
-            <a:ext cx="1920240" cy="182880"/>
+            <a:off x="2514600" y="1755648"/>
+            <a:ext cx="1920240" cy="164592"/>
           </a:xfrm>
           <a:prstGeom prst="rect">
             <a:avLst/>
@@ -4146,8 +4146,8 @@
         </p:nvSpPr>
         <p:spPr>
           <a:xfrm>
-            <a:off x="2606040" y="2148840"/>
-            <a:ext cx="1737360" cy="685800"/>
+            <a:off x="2606040" y="1965960"/>
+            <a:ext cx="1737360" cy="640080"/>
           </a:xfrm>
           <a:prstGeom prst="rect">
             <a:avLst/>
@@ -4219,7 +4219,7 @@
         </p:nvSpPr>
         <p:spPr>
           <a:xfrm>
-            <a:off x="5486400" y="1188720"/>
+            <a:off x="5486400" y="1051560"/>
             <a:ext cx="411480" cy="411480"/>
           </a:xfrm>
           <a:prstGeom prst="ellipse">
@@ -4239,7 +4239,7 @@
         </p:nvSpPr>
         <p:spPr>
           <a:xfrm>
-            <a:off x="5486400" y="1188720"/>
+            <a:off x="5486400" y="1051560"/>
             <a:ext cx="411480" cy="411480"/>
           </a:xfrm>
           <a:prstGeom prst="rect">
@@ -4278,7 +4278,7 @@
         </p:nvSpPr>
         <p:spPr>
           <a:xfrm>
-            <a:off x="5989320" y="1394460"/>
+            <a:off x="5989320" y="1257300"/>
             <a:ext cx="1280160" cy="0"/>
           </a:xfrm>
           <a:prstGeom prst="line">
@@ -4301,8 +4301,8 @@
         </p:nvSpPr>
         <p:spPr>
           <a:xfrm>
-            <a:off x="4754880" y="1691640"/>
-            <a:ext cx="1920240" cy="256032"/>
+            <a:off x="4754880" y="1554480"/>
+            <a:ext cx="1920240" cy="228600"/>
           </a:xfrm>
           <a:prstGeom prst="rect">
             <a:avLst/>
@@ -4340,8 +4340,8 @@
         </p:nvSpPr>
         <p:spPr>
           <a:xfrm>
-            <a:off x="4754880" y="1901952"/>
-            <a:ext cx="1920240" cy="182880"/>
+            <a:off x="4754880" y="1755648"/>
+            <a:ext cx="1920240" cy="164592"/>
           </a:xfrm>
           <a:prstGeom prst="rect">
             <a:avLst/>
@@ -4379,8 +4379,8 @@
         </p:nvSpPr>
         <p:spPr>
           <a:xfrm>
-            <a:off x="4846320" y="2148840"/>
-            <a:ext cx="1737360" cy="685800"/>
+            <a:off x="4846320" y="1965960"/>
+            <a:ext cx="1737360" cy="640080"/>
           </a:xfrm>
           <a:prstGeom prst="rect">
             <a:avLst/>
@@ -4452,7 +4452,7 @@
         </p:nvSpPr>
         <p:spPr>
           <a:xfrm>
-            <a:off x="7726680" y="1188720"/>
+            <a:off x="7726680" y="1051560"/>
             <a:ext cx="411480" cy="411480"/>
           </a:xfrm>
           <a:prstGeom prst="ellipse">
@@ -4472,7 +4472,7 @@
         </p:nvSpPr>
         <p:spPr>
           <a:xfrm>
-            <a:off x="7726680" y="1188720"/>
+            <a:off x="7726680" y="1051560"/>
             <a:ext cx="411480" cy="411480"/>
           </a:xfrm>
           <a:prstGeom prst="rect">
@@ -4511,8 +4511,8 @@
         </p:nvSpPr>
         <p:spPr>
           <a:xfrm>
-            <a:off x="6995160" y="1691640"/>
-            <a:ext cx="1920240" cy="256032"/>
+            <a:off x="6995160" y="1554480"/>
+            <a:ext cx="1920240" cy="228600"/>
           </a:xfrm>
           <a:prstGeom prst="rect">
             <a:avLst/>
@@ -4550,8 +4550,8 @@
         </p:nvSpPr>
         <p:spPr>
           <a:xfrm>
-            <a:off x="6995160" y="1901952"/>
-            <a:ext cx="1920240" cy="182880"/>
+            <a:off x="6995160" y="1755648"/>
+            <a:ext cx="1920240" cy="164592"/>
           </a:xfrm>
           <a:prstGeom prst="rect">
             <a:avLst/>
@@ -4589,8 +4589,8 @@
         </p:nvSpPr>
         <p:spPr>
           <a:xfrm>
-            <a:off x="7086600" y="2148840"/>
-            <a:ext cx="1737360" cy="685800"/>
+            <a:off x="7086600" y="1965960"/>
+            <a:ext cx="1737360" cy="640080"/>
           </a:xfrm>
           <a:prstGeom prst="rect">
             <a:avLst/>
@@ -4662,8 +4662,8 @@
         </p:nvSpPr>
         <p:spPr>
           <a:xfrm>
-            <a:off x="640080" y="3017520"/>
-            <a:ext cx="4572000" cy="228600"/>
+            <a:off x="640080" y="2788920"/>
+            <a:ext cx="4114800" cy="201168"/>
           </a:xfrm>
           <a:prstGeom prst="rect">
             <a:avLst/>
@@ -4687,7 +4687,7 @@
                 <a:ea typeface="Calibri" pitchFamily="34" charset="-122"/>
                 <a:cs typeface="Calibri" pitchFamily="34" charset="-120"/>
               </a:rPr>
-              <a:t>Profili dei 10 Fondatori (selezione strategica)</a:t>
+              <a:t>Profili dei 10 Fondatori</a:t>
             </a:r>
             <a:endParaRPr lang="en-US" sz="1100" dirty="0"/>
           </a:p>
@@ -4701,8 +4701,8 @@
         </p:nvSpPr>
         <p:spPr>
           <a:xfrm>
-            <a:off x="640080" y="3291840"/>
-            <a:ext cx="320040" cy="320040"/>
+            <a:off x="640080" y="3063240"/>
+            <a:ext cx="274320" cy="274320"/>
           </a:xfrm>
           <a:prstGeom prst="rect">
             <a:avLst/>
@@ -4718,7 +4718,7 @@
               <a:buNone/>
             </a:pPr>
             <a:r>
-              <a:rPr lang="en-US" sz="1500" b="1" dirty="0">
+              <a:rPr lang="en-US" sz="1400" b="1" dirty="0">
                 <a:solidFill>
                   <a:srgbClr val="0D9488"/>
                 </a:solidFill>
@@ -4728,7 +4728,7 @@
               </a:rPr>
               <a:t>3</a:t>
             </a:r>
-            <a:endParaRPr lang="en-US" sz="1500" dirty="0"/>
+            <a:endParaRPr lang="en-US" sz="1400" dirty="0"/>
           </a:p>
         </p:txBody>
       </p:sp>
@@ -4740,8 +4740,8 @@
         </p:nvSpPr>
         <p:spPr>
           <a:xfrm>
-            <a:off x="1005840" y="3328416"/>
-            <a:ext cx="2103120" cy="228600"/>
+            <a:off x="960120" y="3090672"/>
+            <a:ext cx="1097280" cy="201168"/>
           </a:xfrm>
           <a:prstGeom prst="rect">
             <a:avLst/>
@@ -4757,7 +4757,7 @@
               <a:buNone/>
             </a:pPr>
             <a:r>
-              <a:rPr lang="en-US" sz="1000" dirty="0">
+              <a:rPr lang="en-US" sz="900" dirty="0">
                 <a:solidFill>
                   <a:srgbClr val="F1F5F9"/>
                 </a:solidFill>
@@ -4767,7 +4767,7 @@
               </a:rPr>
               <a:t>PT in palestra</a:t>
             </a:r>
-            <a:endParaRPr lang="en-US" sz="1000" dirty="0"/>
+            <a:endParaRPr lang="en-US" sz="900" dirty="0"/>
           </a:p>
         </p:txBody>
       </p:sp>
@@ -4779,8 +4779,8 @@
         </p:nvSpPr>
         <p:spPr>
           <a:xfrm>
-            <a:off x="3383280" y="3291840"/>
-            <a:ext cx="320040" cy="320040"/>
+            <a:off x="2148840" y="3063240"/>
+            <a:ext cx="274320" cy="274320"/>
           </a:xfrm>
           <a:prstGeom prst="rect">
             <a:avLst/>
@@ -4796,7 +4796,7 @@
               <a:buNone/>
             </a:pPr>
             <a:r>
-              <a:rPr lang="en-US" sz="1500" b="1" dirty="0">
+              <a:rPr lang="en-US" sz="1400" b="1" dirty="0">
                 <a:solidFill>
                   <a:srgbClr val="0D9488"/>
                 </a:solidFill>
@@ -4806,7 +4806,7 @@
               </a:rPr>
               <a:t>2</a:t>
             </a:r>
-            <a:endParaRPr lang="en-US" sz="1500" dirty="0"/>
+            <a:endParaRPr lang="en-US" sz="1400" dirty="0"/>
           </a:p>
         </p:txBody>
       </p:sp>
@@ -4818,8 +4818,8 @@
         </p:nvSpPr>
         <p:spPr>
           <a:xfrm>
-            <a:off x="3749040" y="3328416"/>
-            <a:ext cx="2103120" cy="228600"/>
+            <a:off x="2468880" y="3090672"/>
+            <a:ext cx="1097280" cy="201168"/>
           </a:xfrm>
           <a:prstGeom prst="rect">
             <a:avLst/>
@@ -4835,7 +4835,7 @@
               <a:buNone/>
             </a:pPr>
             <a:r>
-              <a:rPr lang="en-US" sz="1000" dirty="0">
+              <a:rPr lang="en-US" sz="900" dirty="0">
                 <a:solidFill>
                   <a:srgbClr val="F1F5F9"/>
                 </a:solidFill>
@@ -4845,7 +4845,7 @@
               </a:rPr>
               <a:t>PT freelance</a:t>
             </a:r>
-            <a:endParaRPr lang="en-US" sz="1000" dirty="0"/>
+            <a:endParaRPr lang="en-US" sz="900" dirty="0"/>
           </a:p>
         </p:txBody>
       </p:sp>
@@ -4857,8 +4857,8 @@
         </p:nvSpPr>
         <p:spPr>
           <a:xfrm>
-            <a:off x="6126480" y="3291840"/>
-            <a:ext cx="320040" cy="320040"/>
+            <a:off x="3657600" y="3063240"/>
+            <a:ext cx="274320" cy="274320"/>
           </a:xfrm>
           <a:prstGeom prst="rect">
             <a:avLst/>
@@ -4874,7 +4874,7 @@
               <a:buNone/>
             </a:pPr>
             <a:r>
-              <a:rPr lang="en-US" sz="1500" b="1" dirty="0">
+              <a:rPr lang="en-US" sz="1400" b="1" dirty="0">
                 <a:solidFill>
                   <a:srgbClr val="0D9488"/>
                 </a:solidFill>
@@ -4884,7 +4884,7 @@
               </a:rPr>
               <a:t>2</a:t>
             </a:r>
-            <a:endParaRPr lang="en-US" sz="1500" dirty="0"/>
+            <a:endParaRPr lang="en-US" sz="1400" dirty="0"/>
           </a:p>
         </p:txBody>
       </p:sp>
@@ -4896,8 +4896,8 @@
         </p:nvSpPr>
         <p:spPr>
           <a:xfrm>
-            <a:off x="6492240" y="3328416"/>
-            <a:ext cx="2103120" cy="228600"/>
+            <a:off x="3977640" y="3090672"/>
+            <a:ext cx="1097280" cy="201168"/>
           </a:xfrm>
           <a:prstGeom prst="rect">
             <a:avLst/>
@@ -4913,7 +4913,7 @@
               <a:buNone/>
             </a:pPr>
             <a:r>
-              <a:rPr lang="en-US" sz="1000" dirty="0">
+              <a:rPr lang="en-US" sz="900" dirty="0">
                 <a:solidFill>
                   <a:srgbClr val="F1F5F9"/>
                 </a:solidFill>
@@ -4923,7 +4923,7 @@
               </a:rPr>
               <a:t>Chinesiologi clinici</a:t>
             </a:r>
-            <a:endParaRPr lang="en-US" sz="1000" dirty="0"/>
+            <a:endParaRPr lang="en-US" sz="900" dirty="0"/>
           </a:p>
         </p:txBody>
       </p:sp>
@@ -4935,8 +4935,8 @@
         </p:nvSpPr>
         <p:spPr>
           <a:xfrm>
-            <a:off x="640080" y="3730752"/>
-            <a:ext cx="320040" cy="320040"/>
+            <a:off x="640080" y="3429000"/>
+            <a:ext cx="274320" cy="274320"/>
           </a:xfrm>
           <a:prstGeom prst="rect">
             <a:avLst/>
@@ -4952,7 +4952,7 @@
               <a:buNone/>
             </a:pPr>
             <a:r>
-              <a:rPr lang="en-US" sz="1500" b="1" dirty="0">
+              <a:rPr lang="en-US" sz="1400" b="1" dirty="0">
                 <a:solidFill>
                   <a:srgbClr val="0D9488"/>
                 </a:solidFill>
@@ -4962,7 +4962,7 @@
               </a:rPr>
               <a:t>1</a:t>
             </a:r>
-            <a:endParaRPr lang="en-US" sz="1500" dirty="0"/>
+            <a:endParaRPr lang="en-US" sz="1400" dirty="0"/>
           </a:p>
         </p:txBody>
       </p:sp>
@@ -4974,8 +4974,8 @@
         </p:nvSpPr>
         <p:spPr>
           <a:xfrm>
-            <a:off x="1005840" y="3767328"/>
-            <a:ext cx="2103120" cy="228600"/>
+            <a:off x="960120" y="3456432"/>
+            <a:ext cx="1097280" cy="201168"/>
           </a:xfrm>
           <a:prstGeom prst="rect">
             <a:avLst/>
@@ -4991,7 +4991,7 @@
               <a:buNone/>
             </a:pPr>
             <a:r>
-              <a:rPr lang="en-US" sz="1000" dirty="0">
+              <a:rPr lang="en-US" sz="900" dirty="0">
                 <a:solidFill>
                   <a:srgbClr val="F1F5F9"/>
                 </a:solidFill>
@@ -5001,7 +5001,7 @@
               </a:rPr>
               <a:t>PT online/ibrido</a:t>
             </a:r>
-            <a:endParaRPr lang="en-US" sz="1000" dirty="0"/>
+            <a:endParaRPr lang="en-US" sz="900" dirty="0"/>
           </a:p>
         </p:txBody>
       </p:sp>
@@ -5013,8 +5013,8 @@
         </p:nvSpPr>
         <p:spPr>
           <a:xfrm>
-            <a:off x="3383280" y="3730752"/>
-            <a:ext cx="320040" cy="320040"/>
+            <a:off x="2148840" y="3429000"/>
+            <a:ext cx="274320" cy="274320"/>
           </a:xfrm>
           <a:prstGeom prst="rect">
             <a:avLst/>
@@ -5030,7 +5030,7 @@
               <a:buNone/>
             </a:pPr>
             <a:r>
-              <a:rPr lang="en-US" sz="1500" b="1" dirty="0">
+              <a:rPr lang="en-US" sz="1400" b="1" dirty="0">
                 <a:solidFill>
                   <a:srgbClr val="0D9488"/>
                 </a:solidFill>
@@ -5040,7 +5040,7 @@
               </a:rPr>
               <a:t>1</a:t>
             </a:r>
-            <a:endParaRPr lang="en-US" sz="1500" dirty="0"/>
+            <a:endParaRPr lang="en-US" sz="1400" dirty="0"/>
           </a:p>
         </p:txBody>
       </p:sp>
@@ -5052,8 +5052,8 @@
         </p:nvSpPr>
         <p:spPr>
           <a:xfrm>
-            <a:off x="3749040" y="3767328"/>
-            <a:ext cx="2103120" cy="228600"/>
+            <a:off x="2468880" y="3456432"/>
+            <a:ext cx="1097280" cy="201168"/>
           </a:xfrm>
           <a:prstGeom prst="rect">
             <a:avLst/>
@@ -5069,7 +5069,7 @@
               <a:buNone/>
             </a:pPr>
             <a:r>
-              <a:rPr lang="en-US" sz="1000" dirty="0">
+              <a:rPr lang="en-US" sz="900" dirty="0">
                 <a:solidFill>
                   <a:srgbClr val="F1F5F9"/>
                 </a:solidFill>
@@ -5079,7 +5079,7 @@
               </a:rPr>
               <a:t>PT neoqualificato</a:t>
             </a:r>
-            <a:endParaRPr lang="en-US" sz="1000" dirty="0"/>
+            <a:endParaRPr lang="en-US" sz="900" dirty="0"/>
           </a:p>
         </p:txBody>
       </p:sp>
@@ -5091,8 +5091,8 @@
         </p:nvSpPr>
         <p:spPr>
           <a:xfrm>
-            <a:off x="6126480" y="3730752"/>
-            <a:ext cx="320040" cy="320040"/>
+            <a:off x="3657600" y="3429000"/>
+            <a:ext cx="274320" cy="274320"/>
           </a:xfrm>
           <a:prstGeom prst="rect">
             <a:avLst/>
@@ -5108,7 +5108,7 @@
               <a:buNone/>
             </a:pPr>
             <a:r>
-              <a:rPr lang="en-US" sz="1500" b="1" dirty="0">
+              <a:rPr lang="en-US" sz="1400" b="1" dirty="0">
                 <a:solidFill>
                   <a:srgbClr val="0D9488"/>
                 </a:solidFill>
@@ -5118,7 +5118,7 @@
               </a:rPr>
               <a:t>1</a:t>
             </a:r>
-            <a:endParaRPr lang="en-US" sz="1500" dirty="0"/>
+            <a:endParaRPr lang="en-US" sz="1400" dirty="0"/>
           </a:p>
         </p:txBody>
       </p:sp>
@@ -5130,8 +5130,8 @@
         </p:nvSpPr>
         <p:spPr>
           <a:xfrm>
-            <a:off x="6492240" y="3767328"/>
-            <a:ext cx="2103120" cy="228600"/>
+            <a:off x="3977640" y="3456432"/>
+            <a:ext cx="1097280" cy="201168"/>
           </a:xfrm>
           <a:prstGeom prst="rect">
             <a:avLst/>
@@ -5147,7 +5147,7 @@
               <a:buNone/>
             </a:pPr>
             <a:r>
-              <a:rPr lang="en-US" sz="1000" dirty="0">
+              <a:rPr lang="en-US" sz="900" dirty="0">
                 <a:solidFill>
                   <a:srgbClr val="F1F5F9"/>
                 </a:solidFill>
@@ -5157,7 +5157,7 @@
               </a:rPr>
               <a:t>PT senior (40+ clienti)</a:t>
             </a:r>
-            <a:endParaRPr lang="en-US" sz="1000" dirty="0"/>
+            <a:endParaRPr lang="en-US" sz="900" dirty="0"/>
           </a:p>
         </p:txBody>
       </p:sp>
@@ -5176,19 +5176,19 @@
           </p:nvPr>
         </p:nvGraphicFramePr>
         <p:xfrm>
-          <a:off x="5029200" y="3017520"/>
-          <a:ext cx="3657600" cy="914400"/>
+          <a:off x="4846320" y="2788920"/>
+          <a:ext cx="3840480" cy="914400"/>
         </p:xfrm>
         <a:graphic>
           <a:graphicData uri="http://schemas.openxmlformats.org/drawingml/2006/table">
             <a:tbl>
               <a:tblPr/>
               <a:tblGrid>
-                <a:gridCol w="1554480"/>
+                <a:gridCol w="1645920"/>
                 <a:gridCol w="914400"/>
-                <a:gridCol w="1188720"/>
+                <a:gridCol w="1280160"/>
               </a:tblGrid>
-              <a:tr h="219456">
+              <a:tr h="201168">
                 <a:tc>
                   <a:txBody>
                     <a:bodyPr/>
@@ -5342,7 +5342,7 @@
                           <a:ea typeface="Calibri" pitchFamily="34" charset="-122"/>
                           <a:cs typeface="Calibri" pitchFamily="34" charset="-120"/>
                         </a:rPr>
-                        <a:t>Target 90gg</a:t>
+                        <a:t>Target</a:t>
                       </a:r>
                       <a:endParaRPr lang="en-US" sz="900" dirty="0">
                         <a:latin typeface="Calibri" charset="0"/>
@@ -5394,7 +5394,7 @@
                   </a:tcPr>
                 </a:tc>
               </a:tr>
-              <a:tr h="201168">
+              <a:tr h="182880">
                 <a:tc>
                   <a:txBody>
                     <a:bodyPr/>
@@ -5412,7 +5412,7 @@
                           <a:ea typeface="Calibri" pitchFamily="34" charset="-122"/>
                           <a:cs typeface="Calibri" pitchFamily="34" charset="-120"/>
                         </a:rPr>
-                        <a:t>Ore admin/settimana</a:t>
+                        <a:t>Ore admin/sett.</a:t>
                       </a:r>
                       <a:endParaRPr lang="en-US" sz="900" dirty="0">
                         <a:latin typeface="Calibri" charset="0"/>
@@ -5591,7 +5591,7 @@
                   </a:tcPr>
                 </a:tc>
               </a:tr>
-              <a:tr h="201168">
+              <a:tr h="182880">
                 <a:tc>
                   <a:txBody>
                     <a:bodyPr/>
@@ -5609,7 +5609,7 @@
                           <a:ea typeface="Calibri" pitchFamily="34" charset="-122"/>
                           <a:cs typeface="Calibri" pitchFamily="34" charset="-120"/>
                         </a:rPr>
-                        <a:t>Organizzazione (1-10)</a:t>
+                        <a:t>Organizzazione</a:t>
                       </a:r>
                       <a:endParaRPr lang="en-US" sz="900" dirty="0">
                         <a:latin typeface="Calibri" charset="0"/>
@@ -5674,7 +5674,7 @@
                           <a:ea typeface="Calibri" pitchFamily="34" charset="-122"/>
                           <a:cs typeface="Calibri" pitchFamily="34" charset="-120"/>
                         </a:rPr>
-                        <a:t>4-6</a:t>
+                        <a:t>4-6/10</a:t>
                       </a:r>
                       <a:endParaRPr lang="en-US" sz="900" dirty="0">
                         <a:latin typeface="Calibri" charset="0"/>
@@ -5788,7 +5788,7 @@
                   </a:tcPr>
                 </a:tc>
               </a:tr>
-              <a:tr h="201168">
+              <a:tr h="182880">
                 <a:tc>
                   <a:txBody>
                     <a:bodyPr/>
@@ -5985,7 +5985,7 @@
                   </a:tcPr>
                 </a:tc>
               </a:tr>
-              <a:tr h="201168">
+              <a:tr h="182880">
                 <a:tc>
                   <a:txBody>
                     <a:bodyPr/>
@@ -6003,7 +6003,7 @@
                           <a:ea typeface="Calibri" pitchFamily="34" charset="-122"/>
                           <a:cs typeface="Calibri" pitchFamily="34" charset="-120"/>
                         </a:rPr>
-                        <a:t>Ricomprerebbe a €449?</a:t>
+                        <a:t>Ricomprerebbe €449?</a:t>
                       </a:r>
                       <a:endParaRPr lang="en-US" sz="900" dirty="0">
                         <a:latin typeface="Calibri" charset="0"/>
@@ -6194,8 +6194,8 @@
         </p:nvSpPr>
         <p:spPr>
           <a:xfrm>
-            <a:off x="640080" y="4663440"/>
-            <a:ext cx="7863840" cy="274320"/>
+            <a:off x="640080" y="4434840"/>
+            <a:ext cx="7863840" cy="228600"/>
           </a:xfrm>
           <a:prstGeom prst="rect">
             <a:avLst/>
@@ -6219,7 +6219,7 @@
                 <a:ea typeface="Calibri" pitchFamily="34" charset="-122"/>
                 <a:cs typeface="Calibri" pitchFamily="34" charset="-120"/>
               </a:rPr>
-              <a:t>Output: 10 case study + 10 video + dati aggregati. Se fallisce, costa €200 + tempo. Se funziona, genera tutto il marketing.</a:t>
+              <a:t>Output: 10 case study + 10 video + dati aggregati. Se fallisce, costa €200. Se funziona, genera tutto il marketing.</a:t>
             </a:r>
             <a:endParaRPr lang="en-US" sz="1000" dirty="0"/>
           </a:p>
@@ -7501,8 +7501,8 @@
         </p:nvSpPr>
         <p:spPr>
           <a:xfrm>
-            <a:off x="640080" y="1143000"/>
-            <a:ext cx="7863840" cy="822960"/>
+            <a:off x="640080" y="1097280"/>
+            <a:ext cx="7863840" cy="685800"/>
           </a:xfrm>
           <a:prstGeom prst="rect">
             <a:avLst/>
@@ -7526,8 +7526,8 @@
         </p:nvSpPr>
         <p:spPr>
           <a:xfrm>
-            <a:off x="640080" y="1143000"/>
-            <a:ext cx="45720" cy="822960"/>
+            <a:off x="640080" y="1097280"/>
+            <a:ext cx="45720" cy="685800"/>
           </a:xfrm>
           <a:prstGeom prst="rect">
             <a:avLst/>
@@ -7546,8 +7546,8 @@
         </p:nvSpPr>
         <p:spPr>
           <a:xfrm>
-            <a:off x="868680" y="1216152"/>
-            <a:ext cx="2011680" cy="201168"/>
+            <a:off x="868680" y="1152144"/>
+            <a:ext cx="2011680" cy="182880"/>
           </a:xfrm>
           <a:prstGeom prst="rect">
             <a:avLst/>
@@ -7585,8 +7585,8 @@
         </p:nvSpPr>
         <p:spPr>
           <a:xfrm>
-            <a:off x="868680" y="1435608"/>
-            <a:ext cx="2286000" cy="164592"/>
+            <a:off x="868680" y="1353312"/>
+            <a:ext cx="2286000" cy="146304"/>
           </a:xfrm>
           <a:prstGeom prst="rect">
             <a:avLst/>
@@ -7624,8 +7624,8 @@
         </p:nvSpPr>
         <p:spPr>
           <a:xfrm>
-            <a:off x="3566160" y="1216152"/>
-            <a:ext cx="4480560" cy="685800"/>
+            <a:off x="3383280" y="1152144"/>
+            <a:ext cx="4663440" cy="566928"/>
           </a:xfrm>
           <a:prstGeom prst="rect">
             <a:avLst/>
@@ -7663,8 +7663,8 @@
         </p:nvSpPr>
         <p:spPr>
           <a:xfrm>
-            <a:off x="868680" y="2103120"/>
-            <a:ext cx="7406640" cy="822960"/>
+            <a:off x="868680" y="1901952"/>
+            <a:ext cx="7406640" cy="685800"/>
           </a:xfrm>
           <a:prstGeom prst="rect">
             <a:avLst/>
@@ -7688,8 +7688,8 @@
         </p:nvSpPr>
         <p:spPr>
           <a:xfrm>
-            <a:off x="868680" y="2103120"/>
-            <a:ext cx="45720" cy="822960"/>
+            <a:off x="868680" y="1901952"/>
+            <a:ext cx="45720" cy="685800"/>
           </a:xfrm>
           <a:prstGeom prst="rect">
             <a:avLst/>
@@ -7708,8 +7708,8 @@
         </p:nvSpPr>
         <p:spPr>
           <a:xfrm>
-            <a:off x="1097280" y="2176272"/>
-            <a:ext cx="2011680" cy="201168"/>
+            <a:off x="1097280" y="1956816"/>
+            <a:ext cx="2011680" cy="182880"/>
           </a:xfrm>
           <a:prstGeom prst="rect">
             <a:avLst/>
@@ -7747,8 +7747,8 @@
         </p:nvSpPr>
         <p:spPr>
           <a:xfrm>
-            <a:off x="1097280" y="2395728"/>
-            <a:ext cx="2286000" cy="164592"/>
+            <a:off x="1097280" y="2157984"/>
+            <a:ext cx="2286000" cy="146304"/>
           </a:xfrm>
           <a:prstGeom prst="rect">
             <a:avLst/>
@@ -7786,8 +7786,8 @@
         </p:nvSpPr>
         <p:spPr>
           <a:xfrm>
-            <a:off x="3794760" y="2176272"/>
-            <a:ext cx="4023360" cy="685800"/>
+            <a:off x="3611880" y="1956816"/>
+            <a:ext cx="4206240" cy="566928"/>
           </a:xfrm>
           <a:prstGeom prst="rect">
             <a:avLst/>
@@ -7825,8 +7825,8 @@
         </p:nvSpPr>
         <p:spPr>
           <a:xfrm>
-            <a:off x="1097280" y="3063240"/>
-            <a:ext cx="6949440" cy="822960"/>
+            <a:off x="1097280" y="2706624"/>
+            <a:ext cx="6949440" cy="685800"/>
           </a:xfrm>
           <a:prstGeom prst="rect">
             <a:avLst/>
@@ -7850,8 +7850,8 @@
         </p:nvSpPr>
         <p:spPr>
           <a:xfrm>
-            <a:off x="1097280" y="3063240"/>
-            <a:ext cx="45720" cy="822960"/>
+            <a:off x="1097280" y="2706624"/>
+            <a:ext cx="45720" cy="685800"/>
           </a:xfrm>
           <a:prstGeom prst="rect">
             <a:avLst/>
@@ -7870,8 +7870,8 @@
         </p:nvSpPr>
         <p:spPr>
           <a:xfrm>
-            <a:off x="1325880" y="3136392"/>
-            <a:ext cx="2011680" cy="201168"/>
+            <a:off x="1325880" y="2761488"/>
+            <a:ext cx="2011680" cy="182880"/>
           </a:xfrm>
           <a:prstGeom prst="rect">
             <a:avLst/>
@@ -7909,8 +7909,8 @@
         </p:nvSpPr>
         <p:spPr>
           <a:xfrm>
-            <a:off x="1325880" y="3355848"/>
-            <a:ext cx="2286000" cy="164592"/>
+            <a:off x="1325880" y="2962656"/>
+            <a:ext cx="2286000" cy="146304"/>
           </a:xfrm>
           <a:prstGeom prst="rect">
             <a:avLst/>
@@ -7948,8 +7948,8 @@
         </p:nvSpPr>
         <p:spPr>
           <a:xfrm>
-            <a:off x="4023360" y="3136392"/>
-            <a:ext cx="3566160" cy="685800"/>
+            <a:off x="3840480" y="2761488"/>
+            <a:ext cx="3749040" cy="566928"/>
           </a:xfrm>
           <a:prstGeom prst="rect">
             <a:avLst/>
@@ -7987,8 +7987,8 @@
         </p:nvSpPr>
         <p:spPr>
           <a:xfrm>
-            <a:off x="640080" y="4114800"/>
-            <a:ext cx="4572000" cy="228600"/>
+            <a:off x="640080" y="3611880"/>
+            <a:ext cx="4572000" cy="201168"/>
           </a:xfrm>
           <a:prstGeom prst="rect">
             <a:avLst/>
@@ -8033,7 +8033,7 @@
           </p:nvPr>
         </p:nvGraphicFramePr>
         <p:xfrm>
-          <a:off x="640080" y="4389120"/>
+          <a:off x="640080" y="3840480"/>
           <a:ext cx="7863840" cy="914400"/>
         </p:xfrm>
         <a:graphic>
@@ -8045,7 +8045,7 @@
                 <a:gridCol w="4572000"/>
                 <a:gridCol w="1371600"/>
               </a:tblGrid>
-              <a:tr h="201168">
+              <a:tr h="182880">
                 <a:tc>
                   <a:txBody>
                     <a:bodyPr/>
@@ -8199,7 +8199,7 @@
                           <a:ea typeface="Calibri" pitchFamily="34" charset="-122"/>
                           <a:cs typeface="Calibri" pitchFamily="34" charset="-120"/>
                         </a:rPr>
-                        <a:t>Valore singolo</a:t>
+                        <a:t>Valore</a:t>
                       </a:r>
                       <a:endParaRPr lang="en-US" sz="900" dirty="0">
                         <a:latin typeface="Calibri" charset="0"/>
@@ -8251,7 +8251,7 @@
                   </a:tcPr>
                 </a:tc>
               </a:tr>
-              <a:tr h="164592">
+              <a:tr h="155448">
                 <a:tc>
                   <a:txBody>
                     <a:bodyPr/>
@@ -8448,7 +8448,7 @@
                   </a:tcPr>
                 </a:tc>
               </a:tr>
-              <a:tr h="164592">
+              <a:tr h="155448">
                 <a:tc>
                   <a:txBody>
                     <a:bodyPr/>
@@ -8645,7 +8645,7 @@
                   </a:tcPr>
                 </a:tc>
               </a:tr>
-              <a:tr h="164592">
+              <a:tr h="155448">
                 <a:tc>
                   <a:txBody>
                     <a:bodyPr/>
@@ -8842,7 +8842,7 @@
                   </a:tcPr>
                 </a:tc>
               </a:tr>
-              <a:tr h="164592">
+              <a:tr h="155448">
                 <a:tc>
                   <a:txBody>
                     <a:bodyPr/>
@@ -9039,7 +9039,7 @@
                   </a:tcPr>
                 </a:tc>
               </a:tr>
-              <a:tr h="201168">
+              <a:tr h="182880">
                 <a:tc>
                   <a:txBody>
                     <a:bodyPr/>
@@ -9378,8 +9378,8 @@
         </p:nvSpPr>
         <p:spPr>
           <a:xfrm>
-            <a:off x="457200" y="868680"/>
-            <a:ext cx="1234440" cy="777240"/>
+            <a:off x="457200" y="1051560"/>
+            <a:ext cx="1234440" cy="731520"/>
           </a:xfrm>
           <a:prstGeom prst="rect">
             <a:avLst/>
@@ -9405,8 +9405,8 @@
         </p:nvSpPr>
         <p:spPr>
           <a:xfrm>
-            <a:off x="457200" y="896112"/>
-            <a:ext cx="1234440" cy="411480"/>
+            <a:off x="457200" y="1078992"/>
+            <a:ext cx="1234440" cy="365760"/>
           </a:xfrm>
           <a:prstGeom prst="rect">
             <a:avLst/>
@@ -9444,7 +9444,7 @@
         </p:nvSpPr>
         <p:spPr>
           <a:xfrm>
-            <a:off x="457200" y="1325880"/>
+            <a:off x="457200" y="1463040"/>
             <a:ext cx="1234440" cy="228600"/>
           </a:xfrm>
           <a:prstGeom prst="rect">
@@ -9483,8 +9483,8 @@
         </p:nvSpPr>
         <p:spPr>
           <a:xfrm>
-            <a:off x="1874520" y="868680"/>
-            <a:ext cx="1234440" cy="777240"/>
+            <a:off x="1874520" y="1051560"/>
+            <a:ext cx="1234440" cy="731520"/>
           </a:xfrm>
           <a:prstGeom prst="rect">
             <a:avLst/>
@@ -9510,8 +9510,8 @@
         </p:nvSpPr>
         <p:spPr>
           <a:xfrm>
-            <a:off x="1874520" y="896112"/>
-            <a:ext cx="1234440" cy="411480"/>
+            <a:off x="1874520" y="1078992"/>
+            <a:ext cx="1234440" cy="365760"/>
           </a:xfrm>
           <a:prstGeom prst="rect">
             <a:avLst/>
@@ -9549,7 +9549,7 @@
         </p:nvSpPr>
         <p:spPr>
           <a:xfrm>
-            <a:off x="1874520" y="1325880"/>
+            <a:off x="1874520" y="1463040"/>
             <a:ext cx="1234440" cy="228600"/>
           </a:xfrm>
           <a:prstGeom prst="rect">
@@ -9588,8 +9588,8 @@
         </p:nvSpPr>
         <p:spPr>
           <a:xfrm>
-            <a:off x="3291840" y="868680"/>
-            <a:ext cx="1234440" cy="777240"/>
+            <a:off x="3291840" y="1051560"/>
+            <a:ext cx="1234440" cy="731520"/>
           </a:xfrm>
           <a:prstGeom prst="rect">
             <a:avLst/>
@@ -9615,8 +9615,8 @@
         </p:nvSpPr>
         <p:spPr>
           <a:xfrm>
-            <a:off x="3291840" y="896112"/>
-            <a:ext cx="1234440" cy="411480"/>
+            <a:off x="3291840" y="1078992"/>
+            <a:ext cx="1234440" cy="365760"/>
           </a:xfrm>
           <a:prstGeom prst="rect">
             <a:avLst/>
@@ -9654,7 +9654,7 @@
         </p:nvSpPr>
         <p:spPr>
           <a:xfrm>
-            <a:off x="3291840" y="1325880"/>
+            <a:off x="3291840" y="1463040"/>
             <a:ext cx="1234440" cy="228600"/>
           </a:xfrm>
           <a:prstGeom prst="rect">
@@ -9693,8 +9693,8 @@
         </p:nvSpPr>
         <p:spPr>
           <a:xfrm>
-            <a:off x="4709160" y="868680"/>
-            <a:ext cx="1234440" cy="777240"/>
+            <a:off x="4709160" y="1051560"/>
+            <a:ext cx="1234440" cy="731520"/>
           </a:xfrm>
           <a:prstGeom prst="rect">
             <a:avLst/>
@@ -9720,8 +9720,8 @@
         </p:nvSpPr>
         <p:spPr>
           <a:xfrm>
-            <a:off x="4709160" y="896112"/>
-            <a:ext cx="1234440" cy="411480"/>
+            <a:off x="4709160" y="1078992"/>
+            <a:ext cx="1234440" cy="365760"/>
           </a:xfrm>
           <a:prstGeom prst="rect">
             <a:avLst/>
@@ -9759,7 +9759,7 @@
         </p:nvSpPr>
         <p:spPr>
           <a:xfrm>
-            <a:off x="4709160" y="1325880"/>
+            <a:off x="4709160" y="1463040"/>
             <a:ext cx="1234440" cy="228600"/>
           </a:xfrm>
           <a:prstGeom prst="rect">
@@ -9798,8 +9798,8 @@
         </p:nvSpPr>
         <p:spPr>
           <a:xfrm>
-            <a:off x="6126480" y="868680"/>
-            <a:ext cx="1234440" cy="777240"/>
+            <a:off x="6126480" y="1051560"/>
+            <a:ext cx="1234440" cy="731520"/>
           </a:xfrm>
           <a:prstGeom prst="rect">
             <a:avLst/>
@@ -9825,8 +9825,8 @@
         </p:nvSpPr>
         <p:spPr>
           <a:xfrm>
-            <a:off x="6126480" y="896112"/>
-            <a:ext cx="1234440" cy="411480"/>
+            <a:off x="6126480" y="1078992"/>
+            <a:ext cx="1234440" cy="365760"/>
           </a:xfrm>
           <a:prstGeom prst="rect">
             <a:avLst/>
@@ -9864,7 +9864,7 @@
         </p:nvSpPr>
         <p:spPr>
           <a:xfrm>
-            <a:off x="6126480" y="1325880"/>
+            <a:off x="6126480" y="1463040"/>
             <a:ext cx="1234440" cy="228600"/>
           </a:xfrm>
           <a:prstGeom prst="rect">
@@ -9903,8 +9903,8 @@
         </p:nvSpPr>
         <p:spPr>
           <a:xfrm>
-            <a:off x="7543800" y="868680"/>
-            <a:ext cx="1234440" cy="777240"/>
+            <a:off x="7543800" y="1051560"/>
+            <a:ext cx="1234440" cy="731520"/>
           </a:xfrm>
           <a:prstGeom prst="rect">
             <a:avLst/>
@@ -9930,8 +9930,8 @@
         </p:nvSpPr>
         <p:spPr>
           <a:xfrm>
-            <a:off x="7543800" y="896112"/>
-            <a:ext cx="1234440" cy="411480"/>
+            <a:off x="7543800" y="1078992"/>
+            <a:ext cx="1234440" cy="365760"/>
           </a:xfrm>
           <a:prstGeom prst="rect">
             <a:avLst/>
@@ -9969,7 +9969,7 @@
         </p:nvSpPr>
         <p:spPr>
           <a:xfrm>
-            <a:off x="7543800" y="1325880"/>
+            <a:off x="7543800" y="1463040"/>
             <a:ext cx="1234440" cy="228600"/>
           </a:xfrm>
           <a:prstGeom prst="rect">
@@ -10008,7 +10008,7 @@
         </p:nvSpPr>
         <p:spPr>
           <a:xfrm>
-            <a:off x="640080" y="1874520"/>
+            <a:off x="640080" y="1965960"/>
             <a:ext cx="3657600" cy="228600"/>
           </a:xfrm>
           <a:prstGeom prst="rect">
@@ -10047,8 +10047,8 @@
         </p:nvSpPr>
         <p:spPr>
           <a:xfrm>
-            <a:off x="640080" y="2148840"/>
-            <a:ext cx="3931920" cy="1371600"/>
+            <a:off x="640080" y="2240280"/>
+            <a:ext cx="3931920" cy="1188720"/>
           </a:xfrm>
           <a:prstGeom prst="rect">
             <a:avLst/>
@@ -10159,7 +10159,7 @@
         </p:nvSpPr>
         <p:spPr>
           <a:xfrm>
-            <a:off x="4846320" y="1874520"/>
+            <a:off x="4846320" y="1965960"/>
             <a:ext cx="3657600" cy="228600"/>
           </a:xfrm>
           <a:prstGeom prst="rect">
@@ -10198,8 +10198,8 @@
         </p:nvSpPr>
         <p:spPr>
           <a:xfrm>
-            <a:off x="4846320" y="2148840"/>
-            <a:ext cx="3840480" cy="1371600"/>
+            <a:off x="4846320" y="2240280"/>
+            <a:ext cx="3840480" cy="1188720"/>
           </a:xfrm>
           <a:prstGeom prst="rect">
             <a:avLst/>
@@ -10224,7 +10224,7 @@
                 <a:ea typeface="Calibri" pitchFamily="34" charset="-122"/>
                 <a:cs typeface="Calibri" pitchFamily="34" charset="-120"/>
               </a:rPr>
-              <a:t>Database scientifico proprietario (6 mesi di costruzione)</a:t>
+              <a:t>Database scientifico proprietario (6 mesi)</a:t>
             </a:r>
             <a:endParaRPr lang="en-US" sz="1000" dirty="0"/>
           </a:p>
@@ -10260,7 +10260,7 @@
                 <a:ea typeface="Calibri" pitchFamily="34" charset="-122"/>
                 <a:cs typeface="Calibri" pitchFamily="34" charset="-120"/>
               </a:rPr>
-              <a:t>Safety Engine: 47 condizioni x 80 regole automatiche</a:t>
+              <a:t>Safety Engine: 47 condizioni x 80 regole</a:t>
             </a:r>
             <a:endParaRPr lang="en-US" sz="1000" dirty="0"/>
           </a:p>
@@ -10317,7 +10317,7 @@
           </p:nvPr>
         </p:nvGraphicFramePr>
         <p:xfrm>
-          <a:off x="640080" y="3657600"/>
+          <a:off x="640080" y="3566160"/>
           <a:ext cx="7863840" cy="914400"/>
         </p:xfrm>
         <a:graphic>
@@ -10329,7 +10329,7 @@
                 <a:gridCol w="4754880"/>
                 <a:gridCol w="1188720"/>
               </a:tblGrid>
-              <a:tr h="219456">
+              <a:tr h="192024">
                 <a:tc>
                   <a:txBody>
                     <a:bodyPr/>
@@ -10535,7 +10535,7 @@
                   </a:tcPr>
                 </a:tc>
               </a:tr>
-              <a:tr h="182880">
+              <a:tr h="164592">
                 <a:tc>
                   <a:txBody>
                     <a:bodyPr/>
@@ -10732,7 +10732,7 @@
                   </a:tcPr>
                 </a:tc>
               </a:tr>
-              <a:tr h="182880">
+              <a:tr h="164592">
                 <a:tc>
                   <a:txBody>
                     <a:bodyPr/>
@@ -10929,7 +10929,7 @@
                   </a:tcPr>
                 </a:tc>
               </a:tr>
-              <a:tr h="182880">
+              <a:tr h="164592">
                 <a:tc>
                   <a:txBody>
                     <a:bodyPr/>
@@ -11126,7 +11126,7 @@
                   </a:tcPr>
                 </a:tc>
               </a:tr>
-              <a:tr h="182880">
+              <a:tr h="164592">
                 <a:tc>
                   <a:txBody>
                     <a:bodyPr/>
@@ -11323,7 +11323,7 @@
                   </a:tcPr>
                 </a:tc>
               </a:tr>
-              <a:tr h="182880">
+              <a:tr h="164592">
                 <a:tc>
                   <a:txBody>
                     <a:bodyPr/>
@@ -11520,7 +11520,7 @@
                   </a:tcPr>
                 </a:tc>
               </a:tr>
-              <a:tr h="182880">
+              <a:tr h="164592">
                 <a:tc>
                   <a:txBody>
                     <a:bodyPr/>
@@ -20504,7 +20504,7 @@
                 <a:ea typeface="Calibri" pitchFamily="34" charset="-122"/>
                 <a:cs typeface="Calibri" pitchFamily="34" charset="-120"/>
               </a:rPr>
-              <a:t>Network attivo (formatori, enti, catene)</a:t>
+              <a:t>Network attivo (formatori, enti CONI/FIF/ISSA, catene)</a:t>
             </a:r>
             <a:endParaRPr lang="en-US" sz="1000" dirty="0"/>
           </a:p>
@@ -23950,7 +23950,7 @@
                 <a:ea typeface="Calibri" pitchFamily="34" charset="-122"/>
                 <a:cs typeface="Calibri" pitchFamily="34" charset="-120"/>
               </a:rPr>
-              <a:t>guadagno poco in cash, ma sto costruendo un asset che cresce.  </a:t>
+              <a:t>guadagno poco in cash, ma costruisco un asset che cresce.  </a:t>
             </a:r>
             <a:pPr indent="0" marL="0">
               <a:buNone/>
@@ -23978,7 +23978,7 @@
                 <a:ea typeface="Calibri" pitchFamily="34" charset="-122"/>
                 <a:cs typeface="Calibri" pitchFamily="34" charset="-120"/>
               </a:rPr>
-              <a:t>€18K cash ricorrente + equity in un'azienda che vale €75K+. E continua a crescere.</a:t>
+              <a:t>€18K cash ricorrente + equity in un'azienda che vale €75K+.</a:t>
             </a:r>
             <a:endParaRPr lang="en-US" sz="1000" dirty="0"/>
           </a:p>
@@ -24017,7 +24017,7 @@
                 <a:ea typeface="Calibri" pitchFamily="34" charset="-122"/>
                 <a:cs typeface="Calibri" pitchFamily="34" charset="-120"/>
               </a:rPr>
-              <a:t>Il revenue share sale solo quando salgono i ricavi — non pesa mai su mesi a zero vendite. Costo fisso per il founder: €0.</a:t>
+              <a:t>Il revenue share sale solo quando salgono i ricavi. Costo fisso per il founder: €0.</a:t>
             </a:r>
             <a:endParaRPr lang="en-US" sz="1000" dirty="0"/>
           </a:p>
@@ -27015,7 +27015,7 @@
                 <a:ea typeface="Calibri" pitchFamily="34" charset="-122"/>
                 <a:cs typeface="Calibri" pitchFamily="34" charset="-120"/>
               </a:rPr>
-              <a:t>Cloud sync opzionale + cross-platform</a:t>
+              <a:t>Cloud sync + cross-platform</a:t>
             </a:r>
             <a:endParaRPr lang="en-US" sz="1000" dirty="0"/>
           </a:p>
@@ -33467,7 +33467,7 @@
                 <a:ea typeface="Calibri" pitchFamily="34" charset="-122"/>
                 <a:cs typeface="Calibri" pitchFamily="34" charset="-120"/>
               </a:rPr>
-              <a:t>Registro CONI attivo dal 1 luglio 2023. Nuovo ATECO 85.51.09 per PT. La regolamentazione spinge i professionisti verso strumenti strutturati.</a:t>
+              <a:t>Registro CONI attivo dal 1 luglio 2023. Nuovo ATECO 85.51.09 per PT. La regolamentazione spinge verso strumenti strutturati.</a:t>
             </a:r>
             <a:endParaRPr lang="en-US" sz="1000" dirty="0"/>
           </a:p>
@@ -38032,7 +38032,7 @@
                 <a:ea typeface="Calibri" pitchFamily="34" charset="-122"/>
                 <a:cs typeface="Calibri" pitchFamily="34" charset="-120"/>
               </a:rPr>
-              <a:t>I PT non sanno di aver bisogno di questo — servono 6-12 mesi di category creation. Ma chi educa il mercato, lo possiede. Le aziende che creano una categoria crescono 2,1x piu' velocemente (benchmark B2B). </a:t>
+              <a:t>I PT non sanno di aver bisogno di questo — servono 6-12 mesi di category creation. Chi educa il mercato, lo possiede (crescita 2,1x, benchmark B2B). </a:t>
             </a:r>
             <a:pPr indent="0" marL="0">
               <a:buNone/>
@@ -38046,7 +38046,7 @@
                 <a:ea typeface="Calibri" pitchFamily="34" charset="-122"/>
                 <a:cs typeface="Calibri" pitchFamily="34" charset="-120"/>
               </a:rPr>
-              <a:t>Serve un Industry Partner con credibilita' nel settore — un PT si fida di un pari, non di un software.</a:t>
+              <a:t>Serve un Industry Partner con credibilita' nel settore.</a:t>
             </a:r>
             <a:endParaRPr lang="en-US" sz="1100" dirty="0"/>
           </a:p>
@@ -39124,7 +39124,7 @@
                 <a:ea typeface="Calibri" pitchFamily="34" charset="-122"/>
                 <a:cs typeface="Calibri" pitchFamily="34" charset="-120"/>
               </a:rPr>
-              <a:t>10 poi 20 licenze — numeri credibili, non marketing trick</a:t>
+              <a:t>10 poi 20 licenze — numeri credibili</a:t>
             </a:r>
             <a:endParaRPr lang="en-US" sz="800" dirty="0"/>
           </a:p>
@@ -39202,7 +39202,7 @@
                 <a:ea typeface="Calibri" pitchFamily="34" charset="-122"/>
                 <a:cs typeface="Calibri" pitchFamily="34" charset="-120"/>
               </a:rPr>
-              <a:t>€449 visibile subito → €149 sembra un regalo</a:t>
+              <a:t>€449 visibile → €149 sembra un regalo</a:t>
             </a:r>
             <a:endParaRPr lang="en-US" sz="800" dirty="0"/>
           </a:p>
@@ -39280,7 +39280,7 @@
                 <a:ea typeface="Calibri" pitchFamily="34" charset="-122"/>
                 <a:cs typeface="Calibri" pitchFamily="34" charset="-120"/>
               </a:rPr>
-              <a:t>Upgrade lifetime SOLO per Fondatori — chi aspetta lo perde</a:t>
+              <a:t>Upgrade lifetime SOLO Fondatori</a:t>
             </a:r>
             <a:endParaRPr lang="en-US" sz="800" dirty="0"/>
           </a:p>
@@ -39358,7 +39358,7 @@
                 <a:ea typeface="Calibri" pitchFamily="34" charset="-122"/>
                 <a:cs typeface="Calibri" pitchFamily="34" charset="-120"/>
               </a:rPr>
-              <a:t>Nessun abbonamento. Garanzia 30gg a prezzo pieno</a:t>
+              <a:t>Nessun abbonamento. Garanzia 30gg</a:t>
             </a:r>
             <a:endParaRPr lang="en-US" sz="800" dirty="0"/>
           </a:p>

</xml_diff>

<commit_message>
docs: pitch deck fix numeri BP v3.3 + skills find/marketing-psychology
Pitch deck: 9 sostituzioni chirurgiche (python-pptx) senza toccare
il design — upgrade €4.356, ricavi €94.856, EBITDA €58.205, GTM
30→90 e 90→570, referral corretto, AI-ready, partner generico.
Skills: find-skills e marketing-psychology aggiunte al progetto.

Co-Authored-By: Claude Opus 4.6 (1M context) <noreply@anthropic.com>
</commit_message>
<xml_diff>
--- a/docs/FitManager_PitchDeck.pptx
+++ b/docs/FitManager_PitchDeck.pptx
@@ -3276,6 +3276,10 @@
           </a:solidFill>
           <a:ln/>
         </p:spPr>
+        <p:txBody>
+          <a:bodyPr/>
+          <a:p/>
+        </p:txBody>
       </p:sp>
       <p:pic>
         <p:nvPicPr>
@@ -3398,6 +3402,10 @@
           </a:solidFill>
           <a:ln/>
         </p:spPr>
+        <p:txBody>
+          <a:bodyPr/>
+          <a:p/>
+        </p:txBody>
       </p:sp>
       <p:sp>
         <p:nvSpPr>
@@ -3418,6 +3426,10 @@
           </a:solidFill>
           <a:ln/>
         </p:spPr>
+        <p:txBody>
+          <a:bodyPr/>
+          <a:p/>
+        </p:txBody>
       </p:sp>
       <p:sp>
         <p:nvSpPr>
@@ -3477,6 +3489,10 @@
           </a:solidFill>
           <a:ln/>
         </p:spPr>
+        <p:txBody>
+          <a:bodyPr/>
+          <a:p/>
+        </p:txBody>
       </p:sp>
       <p:sp>
         <p:nvSpPr>
@@ -3536,6 +3552,10 @@
           </a:solidFill>
           <a:ln/>
         </p:spPr>
+        <p:txBody>
+          <a:bodyPr/>
+          <a:p/>
+        </p:txBody>
       </p:sp>
       <p:sp>
         <p:nvSpPr>
@@ -3666,6 +3686,10 @@
           </a:solidFill>
           <a:ln/>
         </p:spPr>
+        <p:txBody>
+          <a:bodyPr/>
+          <a:p/>
+        </p:txBody>
       </p:sp>
       <p:sp>
         <p:nvSpPr>
@@ -3764,6 +3788,10 @@
           </a:solidFill>
           <a:ln/>
         </p:spPr>
+        <p:txBody>
+          <a:bodyPr/>
+          <a:p/>
+        </p:txBody>
       </p:sp>
       <p:sp>
         <p:nvSpPr>
@@ -3826,6 +3854,10 @@
             <a:prstDash val="solid"/>
           </a:ln>
         </p:spPr>
+        <p:txBody>
+          <a:bodyPr/>
+          <a:p/>
+        </p:txBody>
       </p:sp>
       <p:sp>
         <p:nvSpPr>
@@ -3997,6 +4029,10 @@
           </a:solidFill>
           <a:ln/>
         </p:spPr>
+        <p:txBody>
+          <a:bodyPr/>
+          <a:p/>
+        </p:txBody>
       </p:sp>
       <p:sp>
         <p:nvSpPr>
@@ -4059,6 +4095,10 @@
             <a:prstDash val="solid"/>
           </a:ln>
         </p:spPr>
+        <p:txBody>
+          <a:bodyPr/>
+          <a:p/>
+        </p:txBody>
       </p:sp>
       <p:sp>
         <p:nvSpPr>
@@ -4230,6 +4270,10 @@
           </a:solidFill>
           <a:ln/>
         </p:spPr>
+        <p:txBody>
+          <a:bodyPr/>
+          <a:p/>
+        </p:txBody>
       </p:sp>
       <p:sp>
         <p:nvSpPr>
@@ -4292,6 +4336,10 @@
             <a:prstDash val="solid"/>
           </a:ln>
         </p:spPr>
+        <p:txBody>
+          <a:bodyPr/>
+          <a:p/>
+        </p:txBody>
       </p:sp>
       <p:sp>
         <p:nvSpPr>
@@ -4463,6 +4511,10 @@
           </a:solidFill>
           <a:ln/>
         </p:spPr>
+        <p:txBody>
+          <a:bodyPr/>
+          <a:p/>
+        </p:txBody>
       </p:sp>
       <p:sp>
         <p:nvSpPr>
@@ -6276,6 +6328,10 @@
           </a:solidFill>
           <a:ln/>
         </p:spPr>
+        <p:txBody>
+          <a:bodyPr/>
+          <a:p/>
+        </p:txBody>
       </p:sp>
       <p:sp>
         <p:nvSpPr>
@@ -6381,6 +6437,10 @@
             </a:outerShdw>
           </a:effectLst>
         </p:spPr>
+        <p:txBody>
+          <a:bodyPr/>
+          <a:p/>
+        </p:txBody>
       </p:sp>
       <p:sp>
         <p:nvSpPr>
@@ -6401,6 +6461,10 @@
           </a:solidFill>
           <a:ln/>
         </p:spPr>
+        <p:txBody>
+          <a:bodyPr/>
+          <a:p/>
+        </p:txBody>
       </p:sp>
       <p:sp>
         <p:nvSpPr>
@@ -6541,6 +6605,10 @@
             <a:prstDash val="solid"/>
           </a:ln>
         </p:spPr>
+        <p:txBody>
+          <a:bodyPr/>
+          <a:p/>
+        </p:txBody>
       </p:sp>
       <p:sp>
         <p:nvSpPr>
@@ -6651,6 +6719,10 @@
           </a:solidFill>
           <a:ln/>
         </p:spPr>
+        <p:txBody>
+          <a:bodyPr/>
+          <a:p/>
+        </p:txBody>
       </p:sp>
       <p:sp>
         <p:nvSpPr>
@@ -6717,6 +6789,10 @@
             </a:outerShdw>
           </a:effectLst>
         </p:spPr>
+        <p:txBody>
+          <a:bodyPr/>
+          <a:p/>
+        </p:txBody>
       </p:sp>
       <p:sp>
         <p:nvSpPr>
@@ -6737,6 +6813,10 @@
           </a:solidFill>
           <a:ln/>
         </p:spPr>
+        <p:txBody>
+          <a:bodyPr/>
+          <a:p/>
+        </p:txBody>
       </p:sp>
       <p:sp>
         <p:nvSpPr>
@@ -6877,6 +6957,10 @@
             <a:prstDash val="solid"/>
           </a:ln>
         </p:spPr>
+        <p:txBody>
+          <a:bodyPr/>
+          <a:p/>
+        </p:txBody>
       </p:sp>
       <p:sp>
         <p:nvSpPr>
@@ -6987,6 +7071,10 @@
           </a:solidFill>
           <a:ln/>
         </p:spPr>
+        <p:txBody>
+          <a:bodyPr/>
+          <a:p/>
+        </p:txBody>
       </p:sp>
       <p:sp>
         <p:nvSpPr>
@@ -7053,6 +7141,10 @@
             </a:outerShdw>
           </a:effectLst>
         </p:spPr>
+        <p:txBody>
+          <a:bodyPr/>
+          <a:p/>
+        </p:txBody>
       </p:sp>
       <p:sp>
         <p:nvSpPr>
@@ -7073,6 +7165,10 @@
           </a:solidFill>
           <a:ln/>
         </p:spPr>
+        <p:txBody>
+          <a:bodyPr/>
+          <a:p/>
+        </p:txBody>
       </p:sp>
       <p:sp>
         <p:nvSpPr>
@@ -7213,6 +7309,10 @@
             <a:prstDash val="solid"/>
           </a:ln>
         </p:spPr>
+        <p:txBody>
+          <a:bodyPr/>
+          <a:p/>
+        </p:txBody>
       </p:sp>
       <p:sp>
         <p:nvSpPr>
@@ -7323,6 +7423,10 @@
           </a:solidFill>
           <a:ln/>
         </p:spPr>
+        <p:txBody>
+          <a:bodyPr/>
+          <a:p/>
+        </p:txBody>
       </p:sp>
       <p:sp>
         <p:nvSpPr>
@@ -7357,7 +7461,7 @@
                 <a:ea typeface="Calibri" pitchFamily="34" charset="-122"/>
                 <a:cs typeface="Calibri" pitchFamily="34" charset="-120"/>
               </a:rPr>
-              <a:t>800 clienti</a:t>
+              <a:t>570 clienti</a:t>
             </a:r>
             <a:endParaRPr lang="en-US" sz="1400" dirty="0"/>
           </a:p>
@@ -7414,6 +7518,10 @@
           </a:solidFill>
           <a:ln/>
         </p:spPr>
+        <p:txBody>
+          <a:bodyPr/>
+          <a:p/>
+        </p:txBody>
       </p:sp>
       <p:sp>
         <p:nvSpPr>
@@ -7517,6 +7625,10 @@
             <a:prstDash val="solid"/>
           </a:ln>
         </p:spPr>
+        <p:txBody>
+          <a:bodyPr/>
+          <a:p/>
+        </p:txBody>
       </p:sp>
       <p:sp>
         <p:nvSpPr>
@@ -7537,6 +7649,10 @@
           </a:solidFill>
           <a:ln/>
         </p:spPr>
+        <p:txBody>
+          <a:bodyPr/>
+          <a:p/>
+        </p:txBody>
       </p:sp>
       <p:sp>
         <p:nvSpPr>
@@ -7679,6 +7795,10 @@
             <a:prstDash val="solid"/>
           </a:ln>
         </p:spPr>
+        <p:txBody>
+          <a:bodyPr/>
+          <a:p/>
+        </p:txBody>
       </p:sp>
       <p:sp>
         <p:nvSpPr>
@@ -7699,6 +7819,10 @@
           </a:solidFill>
           <a:ln/>
         </p:spPr>
+        <p:txBody>
+          <a:bodyPr/>
+          <a:p/>
+        </p:txBody>
       </p:sp>
       <p:sp>
         <p:nvSpPr>
@@ -7841,6 +7965,10 @@
             <a:prstDash val="solid"/>
           </a:ln>
         </p:spPr>
+        <p:txBody>
+          <a:bodyPr/>
+          <a:p/>
+        </p:txBody>
       </p:sp>
       <p:sp>
         <p:nvSpPr>
@@ -7861,6 +7989,10 @@
           </a:solidFill>
           <a:ln/>
         </p:spPr>
+        <p:txBody>
+          <a:bodyPr/>
+          <a:p/>
+        </p:txBody>
       </p:sp>
       <p:sp>
         <p:nvSpPr>
@@ -9291,6 +9423,10 @@
           </a:solidFill>
           <a:ln/>
         </p:spPr>
+        <p:txBody>
+          <a:bodyPr/>
+          <a:p/>
+        </p:txBody>
       </p:sp>
       <p:sp>
         <p:nvSpPr>
@@ -9396,6 +9532,10 @@
             </a:outerShdw>
           </a:effectLst>
         </p:spPr>
+        <p:txBody>
+          <a:bodyPr/>
+          <a:p/>
+        </p:txBody>
       </p:sp>
       <p:sp>
         <p:nvSpPr>
@@ -9501,6 +9641,10 @@
             </a:outerShdw>
           </a:effectLst>
         </p:spPr>
+        <p:txBody>
+          <a:bodyPr/>
+          <a:p/>
+        </p:txBody>
       </p:sp>
       <p:sp>
         <p:nvSpPr>
@@ -9606,6 +9750,10 @@
             </a:outerShdw>
           </a:effectLst>
         </p:spPr>
+        <p:txBody>
+          <a:bodyPr/>
+          <a:p/>
+        </p:txBody>
       </p:sp>
       <p:sp>
         <p:nvSpPr>
@@ -9711,6 +9859,10 @@
             </a:outerShdw>
           </a:effectLst>
         </p:spPr>
+        <p:txBody>
+          <a:bodyPr/>
+          <a:p/>
+        </p:txBody>
       </p:sp>
       <p:sp>
         <p:nvSpPr>
@@ -9816,6 +9968,10 @@
             </a:outerShdw>
           </a:effectLst>
         </p:spPr>
+        <p:txBody>
+          <a:bodyPr/>
+          <a:p/>
+        </p:txBody>
       </p:sp>
       <p:sp>
         <p:nvSpPr>
@@ -9921,6 +10077,10 @@
             </a:outerShdw>
           </a:effectLst>
         </p:spPr>
+        <p:txBody>
+          <a:bodyPr/>
+          <a:p/>
+        </p:txBody>
       </p:sp>
       <p:sp>
         <p:nvSpPr>
@@ -11772,6 +11932,10 @@
           </a:solidFill>
           <a:ln/>
         </p:spPr>
+        <p:txBody>
+          <a:bodyPr/>
+          <a:p/>
+        </p:txBody>
       </p:sp>
       <p:sp>
         <p:nvSpPr>
@@ -12814,7 +12978,7 @@
                           <a:ea typeface="Calibri" pitchFamily="34" charset="-122"/>
                           <a:cs typeface="Calibri" pitchFamily="34" charset="-120"/>
                         </a:rPr>
-                        <a:t>€95.350</a:t>
+                        <a:t>€94.856</a:t>
                       </a:r>
                       <a:endParaRPr lang="en-US" sz="900" dirty="0">
                         <a:latin typeface="Calibri" charset="0"/>
@@ -13338,7 +13502,7 @@
                           <a:ea typeface="Calibri" pitchFamily="34" charset="-122"/>
                           <a:cs typeface="Calibri" pitchFamily="34" charset="-120"/>
                         </a:rPr>
-                        <a:t>€4.850</a:t>
+                        <a:t>€4.356</a:t>
                       </a:r>
                       <a:endParaRPr lang="en-US" sz="900" dirty="0">
                         <a:latin typeface="Calibri" charset="0"/>
@@ -14124,7 +14288,7 @@
                           <a:ea typeface="Calibri" pitchFamily="34" charset="-122"/>
                           <a:cs typeface="Calibri" pitchFamily="34" charset="-120"/>
                         </a:rPr>
-                        <a:t>-€8.275</a:t>
+                        <a:t>-€8.151</a:t>
                       </a:r>
                       <a:endParaRPr lang="en-US" sz="900" dirty="0">
                         <a:latin typeface="Calibri" charset="0"/>
@@ -14648,7 +14812,7 @@
                           <a:ea typeface="Calibri" pitchFamily="34" charset="-122"/>
                           <a:cs typeface="Calibri" pitchFamily="34" charset="-120"/>
                         </a:rPr>
-                        <a:t>€58.575</a:t>
+                        <a:t>€58.205</a:t>
                       </a:r>
                       <a:endParaRPr lang="en-US" sz="900" dirty="0">
                         <a:latin typeface="Calibri" charset="0"/>
@@ -15172,7 +15336,7 @@
                           <a:ea typeface="Calibri" pitchFamily="34" charset="-122"/>
                           <a:cs typeface="Calibri" pitchFamily="34" charset="-120"/>
                         </a:rPr>
-                        <a:t>-€19.833</a:t>
+                        <a:t>-€19.731</a:t>
                       </a:r>
                       <a:endParaRPr lang="en-US" sz="900" dirty="0">
                         <a:latin typeface="Calibri" charset="0"/>
@@ -15434,7 +15598,7 @@
                           <a:ea typeface="Calibri" pitchFamily="34" charset="-122"/>
                           <a:cs typeface="Calibri" pitchFamily="34" charset="-120"/>
                         </a:rPr>
-                        <a:t>€38.742</a:t>
+                        <a:t>€38.474</a:t>
                       </a:r>
                       <a:endParaRPr lang="en-US" sz="900" dirty="0">
                         <a:latin typeface="Calibri" charset="0"/>
@@ -15659,6 +15823,10 @@
           </a:solidFill>
           <a:ln/>
         </p:spPr>
+        <p:txBody>
+          <a:bodyPr/>
+          <a:p/>
+        </p:txBody>
       </p:sp>
       <p:sp>
         <p:nvSpPr>
@@ -15764,6 +15932,10 @@
             </a:outerShdw>
           </a:effectLst>
         </p:spPr>
+        <p:txBody>
+          <a:bodyPr/>
+          <a:p/>
+        </p:txBody>
       </p:sp>
       <p:sp>
         <p:nvSpPr>
@@ -15869,6 +16041,10 @@
             </a:outerShdw>
           </a:effectLst>
         </p:spPr>
+        <p:txBody>
+          <a:bodyPr/>
+          <a:p/>
+        </p:txBody>
       </p:sp>
       <p:sp>
         <p:nvSpPr>
@@ -15974,6 +16150,10 @@
             </a:outerShdw>
           </a:effectLst>
         </p:spPr>
+        <p:txBody>
+          <a:bodyPr/>
+          <a:p/>
+        </p:txBody>
       </p:sp>
       <p:sp>
         <p:nvSpPr>
@@ -16079,6 +16259,10 @@
             </a:outerShdw>
           </a:effectLst>
         </p:spPr>
+        <p:txBody>
+          <a:bodyPr/>
+          <a:p/>
+        </p:txBody>
       </p:sp>
       <p:sp>
         <p:nvSpPr>
@@ -18306,6 +18490,10 @@
           </a:solidFill>
           <a:ln/>
         </p:spPr>
+        <p:txBody>
+          <a:bodyPr/>
+          <a:p/>
+        </p:txBody>
       </p:sp>
       <p:sp>
         <p:nvSpPr>
@@ -18414,6 +18602,10 @@
           </a:solidFill>
           <a:ln/>
         </p:spPr>
+        <p:txBody>
+          <a:bodyPr/>
+          <a:p/>
+        </p:txBody>
       </p:sp>
       <p:sp>
         <p:nvSpPr>
@@ -19972,6 +20164,10 @@
           </a:solidFill>
           <a:ln/>
         </p:spPr>
+        <p:txBody>
+          <a:bodyPr/>
+          <a:p/>
+        </p:txBody>
       </p:sp>
       <p:sp>
         <p:nvSpPr>
@@ -20038,6 +20234,10 @@
             </a:outerShdw>
           </a:effectLst>
         </p:spPr>
+        <p:txBody>
+          <a:bodyPr/>
+          <a:p/>
+        </p:txBody>
       </p:sp>
       <p:sp>
         <p:nvSpPr>
@@ -20058,6 +20258,10 @@
           </a:solidFill>
           <a:ln/>
         </p:spPr>
+        <p:txBody>
+          <a:bodyPr/>
+          <a:p/>
+        </p:txBody>
       </p:sp>
       <p:sp>
         <p:nvSpPr>
@@ -20314,6 +20518,10 @@
             </a:outerShdw>
           </a:effectLst>
         </p:spPr>
+        <p:txBody>
+          <a:bodyPr/>
+          <a:p/>
+        </p:txBody>
       </p:sp>
       <p:sp>
         <p:nvSpPr>
@@ -20334,6 +20542,10 @@
           </a:solidFill>
           <a:ln/>
         </p:spPr>
+        <p:txBody>
+          <a:bodyPr/>
+          <a:p/>
+        </p:txBody>
       </p:sp>
       <p:sp>
         <p:nvSpPr>
@@ -21482,6 +21694,10 @@
           </a:solidFill>
           <a:ln/>
         </p:spPr>
+        <p:txBody>
+          <a:bodyPr/>
+          <a:p/>
+        </p:txBody>
       </p:sp>
       <p:sp>
         <p:nvSpPr>
@@ -23261,7 +23477,7 @@
                           <a:ea typeface="Calibri" pitchFamily="34" charset="-122"/>
                           <a:cs typeface="Calibri" pitchFamily="34" charset="-120"/>
                         </a:rPr>
-                        <a:t>€8.275</a:t>
+                        <a:t>€8.151</a:t>
                       </a:r>
                       <a:endParaRPr lang="en-US" sz="1000" dirty="0">
                         <a:latin typeface="Calibri" charset="0"/>
@@ -24074,6 +24290,10 @@
           </a:solidFill>
           <a:ln/>
         </p:spPr>
+        <p:txBody>
+          <a:bodyPr/>
+          <a:p/>
+        </p:txBody>
       </p:sp>
       <p:sp>
         <p:nvSpPr>
@@ -24140,6 +24360,10 @@
             </a:outerShdw>
           </a:effectLst>
         </p:spPr>
+        <p:txBody>
+          <a:bodyPr/>
+          <a:p/>
+        </p:txBody>
       </p:sp>
       <p:sp>
         <p:nvSpPr>
@@ -24160,6 +24384,10 @@
           </a:solidFill>
           <a:ln/>
         </p:spPr>
+        <p:txBody>
+          <a:bodyPr/>
+          <a:p/>
+        </p:txBody>
       </p:sp>
       <p:sp>
         <p:nvSpPr>
@@ -24304,6 +24532,10 @@
             </a:outerShdw>
           </a:effectLst>
         </p:spPr>
+        <p:txBody>
+          <a:bodyPr/>
+          <a:p/>
+        </p:txBody>
       </p:sp>
       <p:sp>
         <p:nvSpPr>
@@ -24324,6 +24556,10 @@
           </a:solidFill>
           <a:ln/>
         </p:spPr>
+        <p:txBody>
+          <a:bodyPr/>
+          <a:p/>
+        </p:txBody>
       </p:sp>
       <p:sp>
         <p:nvSpPr>
@@ -24468,6 +24704,10 @@
             </a:outerShdw>
           </a:effectLst>
         </p:spPr>
+        <p:txBody>
+          <a:bodyPr/>
+          <a:p/>
+        </p:txBody>
       </p:sp>
       <p:sp>
         <p:nvSpPr>
@@ -24488,6 +24728,10 @@
           </a:solidFill>
           <a:ln/>
         </p:spPr>
+        <p:txBody>
+          <a:bodyPr/>
+          <a:p/>
+        </p:txBody>
       </p:sp>
       <p:sp>
         <p:nvSpPr>
@@ -24632,6 +24876,10 @@
             </a:outerShdw>
           </a:effectLst>
         </p:spPr>
+        <p:txBody>
+          <a:bodyPr/>
+          <a:p/>
+        </p:txBody>
       </p:sp>
       <p:sp>
         <p:nvSpPr>
@@ -24652,6 +24900,10 @@
           </a:solidFill>
           <a:ln/>
         </p:spPr>
+        <p:txBody>
+          <a:bodyPr/>
+          <a:p/>
+        </p:txBody>
       </p:sp>
       <p:sp>
         <p:nvSpPr>
@@ -24796,6 +25048,10 @@
             </a:outerShdw>
           </a:effectLst>
         </p:spPr>
+        <p:txBody>
+          <a:bodyPr/>
+          <a:p/>
+        </p:txBody>
       </p:sp>
       <p:sp>
         <p:nvSpPr>
@@ -24816,6 +25072,10 @@
           </a:solidFill>
           <a:ln/>
         </p:spPr>
+        <p:txBody>
+          <a:bodyPr/>
+          <a:p/>
+        </p:txBody>
       </p:sp>
       <p:sp>
         <p:nvSpPr>
@@ -24960,6 +25220,10 @@
             </a:outerShdw>
           </a:effectLst>
         </p:spPr>
+        <p:txBody>
+          <a:bodyPr/>
+          <a:p/>
+        </p:txBody>
       </p:sp>
       <p:sp>
         <p:nvSpPr>
@@ -24980,6 +25244,10 @@
           </a:solidFill>
           <a:ln/>
         </p:spPr>
+        <p:txBody>
+          <a:bodyPr/>
+          <a:p/>
+        </p:txBody>
       </p:sp>
       <p:sp>
         <p:nvSpPr>
@@ -25124,6 +25392,10 @@
             </a:outerShdw>
           </a:effectLst>
         </p:spPr>
+        <p:txBody>
+          <a:bodyPr/>
+          <a:p/>
+        </p:txBody>
       </p:sp>
       <p:sp>
         <p:nvSpPr>
@@ -25144,6 +25416,10 @@
           </a:solidFill>
           <a:ln/>
         </p:spPr>
+        <p:txBody>
+          <a:bodyPr/>
+          <a:p/>
+        </p:txBody>
       </p:sp>
       <p:sp>
         <p:nvSpPr>
@@ -25281,6 +25557,10 @@
           </a:solidFill>
           <a:ln/>
         </p:spPr>
+        <p:txBody>
+          <a:bodyPr/>
+          <a:p/>
+        </p:txBody>
       </p:sp>
       <p:sp>
         <p:nvSpPr>
@@ -25372,6 +25652,10 @@
           </a:solidFill>
           <a:ln/>
         </p:spPr>
+        <p:txBody>
+          <a:bodyPr/>
+          <a:p/>
+        </p:txBody>
       </p:sp>
       <p:sp>
         <p:nvSpPr>
@@ -25436,6 +25720,10 @@
             <a:prstDash val="solid"/>
           </a:ln>
         </p:spPr>
+        <p:txBody>
+          <a:bodyPr/>
+          <a:p/>
+        </p:txBody>
       </p:sp>
       <p:sp>
         <p:nvSpPr>
@@ -25456,6 +25744,10 @@
           </a:solidFill>
           <a:ln/>
         </p:spPr>
+        <p:txBody>
+          <a:bodyPr/>
+          <a:p/>
+        </p:txBody>
       </p:sp>
       <p:pic>
         <p:nvPicPr>
@@ -25583,6 +25875,10 @@
             <a:prstDash val="solid"/>
           </a:ln>
         </p:spPr>
+        <p:txBody>
+          <a:bodyPr/>
+          <a:p/>
+        </p:txBody>
       </p:sp>
       <p:sp>
         <p:nvSpPr>
@@ -25603,6 +25899,10 @@
           </a:solidFill>
           <a:ln/>
         </p:spPr>
+        <p:txBody>
+          <a:bodyPr/>
+          <a:p/>
+        </p:txBody>
       </p:sp>
       <p:pic>
         <p:nvPicPr>
@@ -25730,6 +26030,10 @@
             <a:prstDash val="solid"/>
           </a:ln>
         </p:spPr>
+        <p:txBody>
+          <a:bodyPr/>
+          <a:p/>
+        </p:txBody>
       </p:sp>
       <p:sp>
         <p:nvSpPr>
@@ -25750,6 +26054,10 @@
           </a:solidFill>
           <a:ln/>
         </p:spPr>
+        <p:txBody>
+          <a:bodyPr/>
+          <a:p/>
+        </p:txBody>
       </p:sp>
       <p:pic>
         <p:nvPicPr>
@@ -25877,6 +26185,10 @@
             <a:prstDash val="solid"/>
           </a:ln>
         </p:spPr>
+        <p:txBody>
+          <a:bodyPr/>
+          <a:p/>
+        </p:txBody>
       </p:sp>
       <p:sp>
         <p:nvSpPr>
@@ -25897,6 +26209,10 @@
           </a:solidFill>
           <a:ln/>
         </p:spPr>
+        <p:txBody>
+          <a:bodyPr/>
+          <a:p/>
+        </p:txBody>
       </p:sp>
       <p:pic>
         <p:nvPicPr>
@@ -26024,6 +26340,10 @@
             <a:prstDash val="solid"/>
           </a:ln>
         </p:spPr>
+        <p:txBody>
+          <a:bodyPr/>
+          <a:p/>
+        </p:txBody>
       </p:sp>
       <p:sp>
         <p:nvSpPr>
@@ -26044,6 +26364,10 @@
           </a:solidFill>
           <a:ln/>
         </p:spPr>
+        <p:txBody>
+          <a:bodyPr/>
+          <a:p/>
+        </p:txBody>
       </p:sp>
       <p:pic>
         <p:nvPicPr>
@@ -26198,6 +26522,10 @@
           </a:solidFill>
           <a:ln/>
         </p:spPr>
+        <p:txBody>
+          <a:bodyPr/>
+          <a:p/>
+        </p:txBody>
       </p:sp>
       <p:sp>
         <p:nvSpPr>
@@ -26257,6 +26585,10 @@
           </a:solidFill>
           <a:ln/>
         </p:spPr>
+        <p:txBody>
+          <a:bodyPr/>
+          <a:p/>
+        </p:txBody>
       </p:sp>
       <p:sp>
         <p:nvSpPr>
@@ -26394,6 +26726,10 @@
           </a:solidFill>
           <a:ln/>
         </p:spPr>
+        <p:txBody>
+          <a:bodyPr/>
+          <a:p/>
+        </p:txBody>
       </p:sp>
       <p:sp>
         <p:nvSpPr>
@@ -26531,6 +26867,10 @@
           </a:solidFill>
           <a:ln/>
         </p:spPr>
+        <p:txBody>
+          <a:bodyPr/>
+          <a:p/>
+        </p:txBody>
       </p:sp>
       <p:sp>
         <p:nvSpPr>
@@ -26668,6 +27008,10 @@
           </a:solidFill>
           <a:ln/>
         </p:spPr>
+        <p:txBody>
+          <a:bodyPr/>
+          <a:p/>
+        </p:txBody>
       </p:sp>
       <p:sp>
         <p:nvSpPr>
@@ -26805,6 +27149,10 @@
           </a:solidFill>
           <a:ln/>
         </p:spPr>
+        <p:txBody>
+          <a:bodyPr/>
+          <a:p/>
+        </p:txBody>
       </p:sp>
       <p:sp>
         <p:nvSpPr>
@@ -26942,6 +27290,10 @@
           </a:solidFill>
           <a:ln/>
         </p:spPr>
+        <p:txBody>
+          <a:bodyPr/>
+          <a:p/>
+        </p:txBody>
       </p:sp>
       <p:sp>
         <p:nvSpPr>
@@ -27618,6 +27970,10 @@
           </a:solidFill>
           <a:ln/>
         </p:spPr>
+        <p:txBody>
+          <a:bodyPr/>
+          <a:p/>
+        </p:txBody>
       </p:sp>
       <p:sp>
         <p:nvSpPr>
@@ -27721,6 +28077,10 @@
             <a:prstDash val="solid"/>
           </a:ln>
         </p:spPr>
+        <p:txBody>
+          <a:bodyPr/>
+          <a:p/>
+        </p:txBody>
       </p:sp>
       <p:sp>
         <p:nvSpPr>
@@ -27741,6 +28101,10 @@
           </a:solidFill>
           <a:ln/>
         </p:spPr>
+        <p:txBody>
+          <a:bodyPr/>
+          <a:p/>
+        </p:txBody>
       </p:sp>
       <p:pic>
         <p:nvPicPr>
@@ -27924,6 +28288,10 @@
             <a:prstDash val="solid"/>
           </a:ln>
         </p:spPr>
+        <p:txBody>
+          <a:bodyPr/>
+          <a:p/>
+        </p:txBody>
       </p:sp>
       <p:sp>
         <p:nvSpPr>
@@ -27944,6 +28312,10 @@
           </a:solidFill>
           <a:ln/>
         </p:spPr>
+        <p:txBody>
+          <a:bodyPr/>
+          <a:p/>
+        </p:txBody>
       </p:sp>
       <p:pic>
         <p:nvPicPr>
@@ -28127,6 +28499,10 @@
             <a:prstDash val="solid"/>
           </a:ln>
         </p:spPr>
+        <p:txBody>
+          <a:bodyPr/>
+          <a:p/>
+        </p:txBody>
       </p:sp>
       <p:sp>
         <p:nvSpPr>
@@ -28147,6 +28523,10 @@
           </a:solidFill>
           <a:ln/>
         </p:spPr>
+        <p:txBody>
+          <a:bodyPr/>
+          <a:p/>
+        </p:txBody>
       </p:sp>
       <p:pic>
         <p:nvPicPr>
@@ -28330,6 +28710,10 @@
             <a:prstDash val="solid"/>
           </a:ln>
         </p:spPr>
+        <p:txBody>
+          <a:bodyPr/>
+          <a:p/>
+        </p:txBody>
       </p:sp>
       <p:sp>
         <p:nvSpPr>
@@ -28350,6 +28734,10 @@
           </a:solidFill>
           <a:ln/>
         </p:spPr>
+        <p:txBody>
+          <a:bodyPr/>
+          <a:p/>
+        </p:txBody>
       </p:sp>
       <p:pic>
         <p:nvPicPr>
@@ -28528,6 +28916,10 @@
           </a:solidFill>
           <a:ln/>
         </p:spPr>
+        <p:txBody>
+          <a:bodyPr/>
+          <a:p/>
+        </p:txBody>
       </p:sp>
       <p:sp>
         <p:nvSpPr>
@@ -28619,6 +29011,10 @@
           </a:solidFill>
           <a:ln/>
         </p:spPr>
+        <p:txBody>
+          <a:bodyPr/>
+          <a:p/>
+        </p:txBody>
       </p:sp>
       <p:pic>
         <p:nvPicPr>
@@ -28758,6 +29154,10 @@
           </a:solidFill>
           <a:ln/>
         </p:spPr>
+        <p:txBody>
+          <a:bodyPr/>
+          <a:p/>
+        </p:txBody>
       </p:sp>
       <p:sp>
         <p:nvSpPr>
@@ -28922,6 +29322,10 @@
           </a:solidFill>
           <a:ln/>
         </p:spPr>
+        <p:txBody>
+          <a:bodyPr/>
+          <a:p/>
+        </p:txBody>
       </p:sp>
       <p:sp>
         <p:nvSpPr>
@@ -29027,6 +29431,10 @@
             </a:outerShdw>
           </a:effectLst>
         </p:spPr>
+        <p:txBody>
+          <a:bodyPr/>
+          <a:p/>
+        </p:txBody>
       </p:sp>
       <p:sp>
         <p:nvSpPr>
@@ -29047,6 +29455,10 @@
           </a:solidFill>
           <a:ln/>
         </p:spPr>
+        <p:txBody>
+          <a:bodyPr/>
+          <a:p/>
+        </p:txBody>
       </p:sp>
       <p:sp>
         <p:nvSpPr>
@@ -29203,6 +29615,10 @@
             </a:outerShdw>
           </a:effectLst>
         </p:spPr>
+        <p:txBody>
+          <a:bodyPr/>
+          <a:p/>
+        </p:txBody>
       </p:sp>
       <p:sp>
         <p:nvSpPr>
@@ -29223,6 +29639,10 @@
           </a:solidFill>
           <a:ln/>
         </p:spPr>
+        <p:txBody>
+          <a:bodyPr/>
+          <a:p/>
+        </p:txBody>
       </p:sp>
       <p:sp>
         <p:nvSpPr>
@@ -29396,6 +29816,10 @@
             </a:outerShdw>
           </a:effectLst>
         </p:spPr>
+        <p:txBody>
+          <a:bodyPr/>
+          <a:p/>
+        </p:txBody>
       </p:sp>
       <p:sp>
         <p:nvSpPr>
@@ -29416,6 +29840,10 @@
           </a:solidFill>
           <a:ln/>
         </p:spPr>
+        <p:txBody>
+          <a:bodyPr/>
+          <a:p/>
+        </p:txBody>
       </p:sp>
       <p:sp>
         <p:nvSpPr>
@@ -31072,6 +31500,10 @@
           </a:solidFill>
           <a:ln/>
         </p:spPr>
+        <p:txBody>
+          <a:bodyPr/>
+          <a:p/>
+        </p:txBody>
       </p:sp>
       <p:sp>
         <p:nvSpPr>
@@ -31138,6 +31570,10 @@
             </a:outerShdw>
           </a:effectLst>
         </p:spPr>
+        <p:txBody>
+          <a:bodyPr/>
+          <a:p/>
+        </p:txBody>
       </p:sp>
       <p:sp>
         <p:nvSpPr>
@@ -31158,6 +31594,10 @@
           </a:solidFill>
           <a:ln/>
         </p:spPr>
+        <p:txBody>
+          <a:bodyPr/>
+          <a:p/>
+        </p:txBody>
       </p:sp>
       <p:sp>
         <p:nvSpPr>
@@ -31238,6 +31678,10 @@
             </a:outerShdw>
           </a:effectLst>
         </p:spPr>
+        <p:txBody>
+          <a:bodyPr/>
+          <a:p/>
+        </p:txBody>
       </p:sp>
       <p:sp>
         <p:nvSpPr>
@@ -31258,6 +31702,10 @@
           </a:solidFill>
           <a:ln/>
         </p:spPr>
+        <p:txBody>
+          <a:bodyPr/>
+          <a:p/>
+        </p:txBody>
       </p:sp>
       <p:pic>
         <p:nvPicPr>
@@ -31387,6 +31835,10 @@
             </a:outerShdw>
           </a:effectLst>
         </p:spPr>
+        <p:txBody>
+          <a:bodyPr/>
+          <a:p/>
+        </p:txBody>
       </p:sp>
       <p:sp>
         <p:nvSpPr>
@@ -31407,6 +31859,10 @@
           </a:solidFill>
           <a:ln/>
         </p:spPr>
+        <p:txBody>
+          <a:bodyPr/>
+          <a:p/>
+        </p:txBody>
       </p:sp>
       <p:pic>
         <p:nvPicPr>
@@ -31536,6 +31992,10 @@
             </a:outerShdw>
           </a:effectLst>
         </p:spPr>
+        <p:txBody>
+          <a:bodyPr/>
+          <a:p/>
+        </p:txBody>
       </p:sp>
       <p:sp>
         <p:nvSpPr>
@@ -31556,6 +32016,10 @@
           </a:solidFill>
           <a:ln/>
         </p:spPr>
+        <p:txBody>
+          <a:bodyPr/>
+          <a:p/>
+        </p:txBody>
       </p:sp>
       <p:pic>
         <p:nvPicPr>
@@ -31685,6 +32149,10 @@
             </a:outerShdw>
           </a:effectLst>
         </p:spPr>
+        <p:txBody>
+          <a:bodyPr/>
+          <a:p/>
+        </p:txBody>
       </p:sp>
       <p:sp>
         <p:nvSpPr>
@@ -31705,6 +32173,10 @@
           </a:solidFill>
           <a:ln/>
         </p:spPr>
+        <p:txBody>
+          <a:bodyPr/>
+          <a:p/>
+        </p:txBody>
       </p:sp>
       <p:pic>
         <p:nvPicPr>
@@ -31834,6 +32306,10 @@
             </a:outerShdw>
           </a:effectLst>
         </p:spPr>
+        <p:txBody>
+          <a:bodyPr/>
+          <a:p/>
+        </p:txBody>
       </p:sp>
       <p:sp>
         <p:nvSpPr>
@@ -31854,6 +32330,10 @@
           </a:solidFill>
           <a:ln/>
         </p:spPr>
+        <p:txBody>
+          <a:bodyPr/>
+          <a:p/>
+        </p:txBody>
       </p:sp>
       <p:pic>
         <p:nvPicPr>
@@ -31983,6 +32463,10 @@
             </a:outerShdw>
           </a:effectLst>
         </p:spPr>
+        <p:txBody>
+          <a:bodyPr/>
+          <a:p/>
+        </p:txBody>
       </p:sp>
       <p:sp>
         <p:nvSpPr>
@@ -32003,6 +32487,10 @@
           </a:solidFill>
           <a:ln/>
         </p:spPr>
+        <p:txBody>
+          <a:bodyPr/>
+          <a:p/>
+        </p:txBody>
       </p:sp>
       <p:pic>
         <p:nvPicPr>
@@ -32196,6 +32684,10 @@
           </a:solidFill>
           <a:ln/>
         </p:spPr>
+        <p:txBody>
+          <a:bodyPr/>
+          <a:p/>
+        </p:txBody>
       </p:sp>
       <p:sp>
         <p:nvSpPr>
@@ -32299,6 +32791,10 @@
             <a:prstDash val="solid"/>
           </a:ln>
         </p:spPr>
+        <p:txBody>
+          <a:bodyPr/>
+          <a:p/>
+        </p:txBody>
       </p:sp>
       <p:sp>
         <p:nvSpPr>
@@ -32319,6 +32815,10 @@
           </a:solidFill>
           <a:ln/>
         </p:spPr>
+        <p:txBody>
+          <a:bodyPr/>
+          <a:p/>
+        </p:txBody>
       </p:sp>
       <p:pic>
         <p:nvPicPr>
@@ -32446,6 +32946,10 @@
             <a:prstDash val="solid"/>
           </a:ln>
         </p:spPr>
+        <p:txBody>
+          <a:bodyPr/>
+          <a:p/>
+        </p:txBody>
       </p:sp>
       <p:sp>
         <p:nvSpPr>
@@ -32466,6 +32970,10 @@
           </a:solidFill>
           <a:ln/>
         </p:spPr>
+        <p:txBody>
+          <a:bodyPr/>
+          <a:p/>
+        </p:txBody>
       </p:sp>
       <p:pic>
         <p:nvPicPr>
@@ -32593,6 +33101,10 @@
             <a:prstDash val="solid"/>
           </a:ln>
         </p:spPr>
+        <p:txBody>
+          <a:bodyPr/>
+          <a:p/>
+        </p:txBody>
       </p:sp>
       <p:sp>
         <p:nvSpPr>
@@ -32613,6 +33125,10 @@
           </a:solidFill>
           <a:ln/>
         </p:spPr>
+        <p:txBody>
+          <a:bodyPr/>
+          <a:p/>
+        </p:txBody>
       </p:sp>
       <p:pic>
         <p:nvPicPr>
@@ -32740,6 +33256,10 @@
             <a:prstDash val="solid"/>
           </a:ln>
         </p:spPr>
+        <p:txBody>
+          <a:bodyPr/>
+          <a:p/>
+        </p:txBody>
       </p:sp>
       <p:sp>
         <p:nvSpPr>
@@ -32760,6 +33280,10 @@
           </a:solidFill>
           <a:ln/>
         </p:spPr>
+        <p:txBody>
+          <a:bodyPr/>
+          <a:p/>
+        </p:txBody>
       </p:sp>
       <p:pic>
         <p:nvPicPr>
@@ -32887,6 +33411,10 @@
             <a:prstDash val="solid"/>
           </a:ln>
         </p:spPr>
+        <p:txBody>
+          <a:bodyPr/>
+          <a:p/>
+        </p:txBody>
       </p:sp>
       <p:sp>
         <p:nvSpPr>
@@ -32907,6 +33435,10 @@
           </a:solidFill>
           <a:ln/>
         </p:spPr>
+        <p:txBody>
+          <a:bodyPr/>
+          <a:p/>
+        </p:txBody>
       </p:sp>
       <p:pic>
         <p:nvPicPr>
@@ -33034,6 +33566,10 @@
             <a:prstDash val="solid"/>
           </a:ln>
         </p:spPr>
+        <p:txBody>
+          <a:bodyPr/>
+          <a:p/>
+        </p:txBody>
       </p:sp>
       <p:sp>
         <p:nvSpPr>
@@ -33054,6 +33590,10 @@
           </a:solidFill>
           <a:ln/>
         </p:spPr>
+        <p:txBody>
+          <a:bodyPr/>
+          <a:p/>
+        </p:txBody>
       </p:sp>
       <p:pic>
         <p:nvPicPr>
@@ -33247,6 +33787,10 @@
           </a:solidFill>
           <a:ln/>
         </p:spPr>
+        <p:txBody>
+          <a:bodyPr/>
+          <a:p/>
+        </p:txBody>
       </p:sp>
       <p:sp>
         <p:nvSpPr>
@@ -33350,6 +33894,10 @@
             <a:prstDash val="solid"/>
           </a:ln>
         </p:spPr>
+        <p:txBody>
+          <a:bodyPr/>
+          <a:p/>
+        </p:txBody>
       </p:sp>
       <p:sp>
         <p:nvSpPr>
@@ -33370,6 +33918,10 @@
           </a:solidFill>
           <a:ln/>
         </p:spPr>
+        <p:txBody>
+          <a:bodyPr/>
+          <a:p/>
+        </p:txBody>
       </p:sp>
       <p:pic>
         <p:nvPicPr>
@@ -33497,6 +34049,10 @@
             <a:prstDash val="solid"/>
           </a:ln>
         </p:spPr>
+        <p:txBody>
+          <a:bodyPr/>
+          <a:p/>
+        </p:txBody>
       </p:sp>
       <p:sp>
         <p:nvSpPr>
@@ -33517,6 +34073,10 @@
           </a:solidFill>
           <a:ln/>
         </p:spPr>
+        <p:txBody>
+          <a:bodyPr/>
+          <a:p/>
+        </p:txBody>
       </p:sp>
       <p:pic>
         <p:nvPicPr>
@@ -33644,6 +34204,10 @@
             <a:prstDash val="solid"/>
           </a:ln>
         </p:spPr>
+        <p:txBody>
+          <a:bodyPr/>
+          <a:p/>
+        </p:txBody>
       </p:sp>
       <p:sp>
         <p:nvSpPr>
@@ -33664,6 +34228,10 @@
           </a:solidFill>
           <a:ln/>
         </p:spPr>
+        <p:txBody>
+          <a:bodyPr/>
+          <a:p/>
+        </p:txBody>
       </p:sp>
       <p:pic>
         <p:nvPicPr>
@@ -33791,6 +34359,10 @@
             <a:prstDash val="solid"/>
           </a:ln>
         </p:spPr>
+        <p:txBody>
+          <a:bodyPr/>
+          <a:p/>
+        </p:txBody>
       </p:sp>
       <p:sp>
         <p:nvSpPr>
@@ -33811,6 +34383,10 @@
           </a:solidFill>
           <a:ln/>
         </p:spPr>
+        <p:txBody>
+          <a:bodyPr/>
+          <a:p/>
+        </p:txBody>
       </p:sp>
       <p:pic>
         <p:nvPicPr>
@@ -33869,7 +34445,7 @@
                 <a:ea typeface="Calibri" pitchFamily="34" charset="-122"/>
                 <a:cs typeface="Calibri" pitchFamily="34" charset="-120"/>
               </a:rPr>
-              <a:t>AI come moltiplicatore</a:t>
+              <a:t>Architettura AI-ready</a:t>
             </a:r>
             <a:endParaRPr lang="en-US" sz="1300" dirty="0"/>
           </a:p>
@@ -33965,6 +34541,10 @@
           </a:solidFill>
           <a:ln/>
         </p:spPr>
+        <p:txBody>
+          <a:bodyPr/>
+          <a:p/>
+        </p:txBody>
       </p:sp>
       <p:sp>
         <p:nvSpPr>
@@ -34109,6 +34689,10 @@
             </a:outerShdw>
           </a:effectLst>
         </p:spPr>
+        <p:txBody>
+          <a:bodyPr/>
+          <a:p/>
+        </p:txBody>
       </p:sp>
       <p:sp>
         <p:nvSpPr>
@@ -34231,6 +34815,10 @@
             </a:outerShdw>
           </a:effectLst>
         </p:spPr>
+        <p:txBody>
+          <a:bodyPr/>
+          <a:p/>
+        </p:txBody>
       </p:sp>
       <p:sp>
         <p:nvSpPr>
@@ -34353,6 +34941,10 @@
             </a:outerShdw>
           </a:effectLst>
         </p:spPr>
+        <p:txBody>
+          <a:bodyPr/>
+          <a:p/>
+        </p:txBody>
       </p:sp>
       <p:sp>
         <p:nvSpPr>
@@ -36943,6 +37535,10 @@
           </a:solidFill>
           <a:ln/>
         </p:spPr>
+        <p:txBody>
+          <a:bodyPr/>
+          <a:p/>
+        </p:txBody>
       </p:sp>
       <p:sp>
         <p:nvSpPr>
@@ -37124,6 +37720,10 @@
             <a:prstDash val="solid"/>
           </a:ln>
         </p:spPr>
+        <p:txBody>
+          <a:bodyPr/>
+          <a:p/>
+        </p:txBody>
       </p:sp>
       <p:sp>
         <p:nvSpPr>
@@ -37144,6 +37744,10 @@
           </a:solidFill>
           <a:ln/>
         </p:spPr>
+        <p:txBody>
+          <a:bodyPr/>
+          <a:p/>
+        </p:txBody>
       </p:sp>
       <p:sp>
         <p:nvSpPr>
@@ -37169,6 +37773,10 @@
             <a:prstDash val="solid"/>
           </a:ln>
         </p:spPr>
+        <p:txBody>
+          <a:bodyPr/>
+          <a:p/>
+        </p:txBody>
       </p:sp>
       <p:sp>
         <p:nvSpPr>
@@ -37189,6 +37797,10 @@
           </a:solidFill>
           <a:ln/>
         </p:spPr>
+        <p:txBody>
+          <a:bodyPr/>
+          <a:p/>
+        </p:txBody>
       </p:sp>
       <p:sp>
         <p:nvSpPr>
@@ -37292,6 +37904,10 @@
             <a:prstDash val="solid"/>
           </a:ln>
         </p:spPr>
+        <p:txBody>
+          <a:bodyPr/>
+          <a:p/>
+        </p:txBody>
       </p:sp>
       <p:sp>
         <p:nvSpPr>
@@ -37312,6 +37928,10 @@
           </a:solidFill>
           <a:ln/>
         </p:spPr>
+        <p:txBody>
+          <a:bodyPr/>
+          <a:p/>
+        </p:txBody>
       </p:sp>
       <p:sp>
         <p:nvSpPr>
@@ -37337,6 +37957,10 @@
             <a:prstDash val="solid"/>
           </a:ln>
         </p:spPr>
+        <p:txBody>
+          <a:bodyPr/>
+          <a:p/>
+        </p:txBody>
       </p:sp>
       <p:sp>
         <p:nvSpPr>
@@ -37357,6 +37981,10 @@
           </a:solidFill>
           <a:ln/>
         </p:spPr>
+        <p:txBody>
+          <a:bodyPr/>
+          <a:p/>
+        </p:txBody>
       </p:sp>
       <p:sp>
         <p:nvSpPr>
@@ -37460,6 +38088,10 @@
             <a:prstDash val="solid"/>
           </a:ln>
         </p:spPr>
+        <p:txBody>
+          <a:bodyPr/>
+          <a:p/>
+        </p:txBody>
       </p:sp>
       <p:sp>
         <p:nvSpPr>
@@ -37480,6 +38112,10 @@
           </a:solidFill>
           <a:ln/>
         </p:spPr>
+        <p:txBody>
+          <a:bodyPr/>
+          <a:p/>
+        </p:txBody>
       </p:sp>
       <p:sp>
         <p:nvSpPr>
@@ -37505,6 +38141,10 @@
             <a:prstDash val="solid"/>
           </a:ln>
         </p:spPr>
+        <p:txBody>
+          <a:bodyPr/>
+          <a:p/>
+        </p:txBody>
       </p:sp>
       <p:sp>
         <p:nvSpPr>
@@ -37525,6 +38165,10 @@
           </a:solidFill>
           <a:ln/>
         </p:spPr>
+        <p:txBody>
+          <a:bodyPr/>
+          <a:p/>
+        </p:txBody>
       </p:sp>
       <p:sp>
         <p:nvSpPr>
@@ -37628,6 +38272,10 @@
             <a:prstDash val="solid"/>
           </a:ln>
         </p:spPr>
+        <p:txBody>
+          <a:bodyPr/>
+          <a:p/>
+        </p:txBody>
       </p:sp>
       <p:sp>
         <p:nvSpPr>
@@ -37648,6 +38296,10 @@
           </a:solidFill>
           <a:ln/>
         </p:spPr>
+        <p:txBody>
+          <a:bodyPr/>
+          <a:p/>
+        </p:txBody>
       </p:sp>
       <p:sp>
         <p:nvSpPr>
@@ -37673,6 +38325,10 @@
             <a:prstDash val="solid"/>
           </a:ln>
         </p:spPr>
+        <p:txBody>
+          <a:bodyPr/>
+          <a:p/>
+        </p:txBody>
       </p:sp>
       <p:sp>
         <p:nvSpPr>
@@ -37693,6 +38349,10 @@
           </a:solidFill>
           <a:ln/>
         </p:spPr>
+        <p:txBody>
+          <a:bodyPr/>
+          <a:p/>
+        </p:txBody>
       </p:sp>
       <p:sp>
         <p:nvSpPr>
@@ -37796,6 +38456,10 @@
             <a:prstDash val="solid"/>
           </a:ln>
         </p:spPr>
+        <p:txBody>
+          <a:bodyPr/>
+          <a:p/>
+        </p:txBody>
       </p:sp>
       <p:sp>
         <p:nvSpPr>
@@ -37816,6 +38480,10 @@
           </a:solidFill>
           <a:ln/>
         </p:spPr>
+        <p:txBody>
+          <a:bodyPr/>
+          <a:p/>
+        </p:txBody>
       </p:sp>
       <p:sp>
         <p:nvSpPr>
@@ -37841,6 +38509,10 @@
             <a:prstDash val="solid"/>
           </a:ln>
         </p:spPr>
+        <p:txBody>
+          <a:bodyPr/>
+          <a:p/>
+        </p:txBody>
       </p:sp>
       <p:sp>
         <p:nvSpPr>
@@ -37861,6 +38533,10 @@
           </a:solidFill>
           <a:ln/>
         </p:spPr>
+        <p:txBody>
+          <a:bodyPr/>
+          <a:p/>
+        </p:txBody>
       </p:sp>
       <p:sp>
         <p:nvSpPr>
@@ -37964,6 +38640,10 @@
             <a:prstDash val="solid"/>
           </a:ln>
         </p:spPr>
+        <p:txBody>
+          <a:bodyPr/>
+          <a:p/>
+        </p:txBody>
       </p:sp>
       <p:sp>
         <p:nvSpPr>
@@ -37984,6 +38664,10 @@
           </a:solidFill>
           <a:ln/>
         </p:spPr>
+        <p:txBody>
+          <a:bodyPr/>
+          <a:p/>
+        </p:txBody>
       </p:sp>
       <p:sp>
         <p:nvSpPr>
@@ -38103,6 +38787,10 @@
           </a:solidFill>
           <a:ln/>
         </p:spPr>
+        <p:txBody>
+          <a:bodyPr/>
+          <a:p/>
+        </p:txBody>
       </p:sp>
       <p:sp>
         <p:nvSpPr>
@@ -38208,6 +38896,10 @@
             </a:outerShdw>
           </a:effectLst>
         </p:spPr>
+        <p:txBody>
+          <a:bodyPr/>
+          <a:p/>
+        </p:txBody>
       </p:sp>
       <p:sp>
         <p:nvSpPr>
@@ -38228,6 +38920,10 @@
           </a:solidFill>
           <a:ln/>
         </p:spPr>
+        <p:txBody>
+          <a:bodyPr/>
+          <a:p/>
+        </p:txBody>
       </p:sp>
       <p:sp>
         <p:nvSpPr>
@@ -38368,6 +39064,10 @@
             <a:prstDash val="solid"/>
           </a:ln>
         </p:spPr>
+        <p:txBody>
+          <a:bodyPr/>
+          <a:p/>
+        </p:txBody>
       </p:sp>
       <p:sp>
         <p:nvSpPr>
@@ -38485,6 +39185,10 @@
             </a:outerShdw>
           </a:effectLst>
         </p:spPr>
+        <p:txBody>
+          <a:bodyPr/>
+          <a:p/>
+        </p:txBody>
       </p:sp>
       <p:sp>
         <p:nvSpPr>
@@ -38505,6 +39209,10 @@
           </a:solidFill>
           <a:ln/>
         </p:spPr>
+        <p:txBody>
+          <a:bodyPr/>
+          <a:p/>
+        </p:txBody>
       </p:sp>
       <p:sp>
         <p:nvSpPr>
@@ -38645,6 +39353,10 @@
             <a:prstDash val="solid"/>
           </a:ln>
         </p:spPr>
+        <p:txBody>
+          <a:bodyPr/>
+          <a:p/>
+        </p:txBody>
       </p:sp>
       <p:sp>
         <p:nvSpPr>
@@ -38762,6 +39474,10 @@
             </a:outerShdw>
           </a:effectLst>
         </p:spPr>
+        <p:txBody>
+          <a:bodyPr/>
+          <a:p/>
+        </p:txBody>
       </p:sp>
       <p:sp>
         <p:nvSpPr>
@@ -38782,6 +39498,10 @@
           </a:solidFill>
           <a:ln/>
         </p:spPr>
+        <p:txBody>
+          <a:bodyPr/>
+          <a:p/>
+        </p:txBody>
       </p:sp>
       <p:sp>
         <p:nvSpPr>
@@ -38922,6 +39642,10 @@
             <a:prstDash val="solid"/>
           </a:ln>
         </p:spPr>
+        <p:txBody>
+          <a:bodyPr/>
+          <a:p/>
+        </p:txBody>
       </p:sp>
       <p:sp>
         <p:nvSpPr>
@@ -39415,6 +40139,10 @@
           </a:solidFill>
           <a:ln/>
         </p:spPr>
+        <p:txBody>
+          <a:bodyPr/>
+          <a:p/>
+        </p:txBody>
       </p:sp>
       <p:sp>
         <p:nvSpPr>
@@ -39520,6 +40248,10 @@
             </a:outerShdw>
           </a:effectLst>
         </p:spPr>
+        <p:txBody>
+          <a:bodyPr/>
+          <a:p/>
+        </p:txBody>
       </p:sp>
       <p:sp>
         <p:nvSpPr>
@@ -39540,6 +40272,10 @@
           </a:solidFill>
           <a:ln/>
         </p:spPr>
+        <p:txBody>
+          <a:bodyPr/>
+          <a:p/>
+        </p:txBody>
       </p:sp>
       <p:sp>
         <p:nvSpPr>
@@ -41103,6 +41839,10 @@
             </a:outerShdw>
           </a:effectLst>
         </p:spPr>
+        <p:txBody>
+          <a:bodyPr/>
+          <a:p/>
+        </p:txBody>
       </p:sp>
       <p:sp>
         <p:nvSpPr>
@@ -41123,6 +41863,10 @@
           </a:solidFill>
           <a:ln/>
         </p:spPr>
+        <p:txBody>
+          <a:bodyPr/>
+          <a:p/>
+        </p:txBody>
       </p:sp>
       <p:sp>
         <p:nvSpPr>

</xml_diff>